<commit_message>
added the second ppt
</commit_message>
<xml_diff>
--- a/Customer_Retention_Intelligence_System_Pitch_and_Technical.pptx
+++ b/Customer_Retention_Intelligence_System_Pitch_and_Technical.pptx
@@ -5,27 +5,27 @@
     <p:sldMasterId id="2147483648" r:id="rId1"/>
   </p:sldMasterIdLst>
   <p:sldIdLst>
-    <p:sldId id="256" r:id="rId7"/>
-    <p:sldId id="257" r:id="rId8"/>
-    <p:sldId id="258" r:id="rId9"/>
-    <p:sldId id="259" r:id="rId10"/>
-    <p:sldId id="260" r:id="rId11"/>
-    <p:sldId id="261" r:id="rId12"/>
-    <p:sldId id="262" r:id="rId13"/>
-    <p:sldId id="263" r:id="rId14"/>
-    <p:sldId id="264" r:id="rId15"/>
-    <p:sldId id="265" r:id="rId16"/>
-    <p:sldId id="266" r:id="rId17"/>
-    <p:sldId id="267" r:id="rId18"/>
-    <p:sldId id="268" r:id="rId19"/>
-    <p:sldId id="269" r:id="rId20"/>
-    <p:sldId id="270" r:id="rId21"/>
-    <p:sldId id="271" r:id="rId22"/>
-    <p:sldId id="272" r:id="rId23"/>
-    <p:sldId id="273" r:id="rId24"/>
-    <p:sldId id="274" r:id="rId25"/>
+    <p:sldId id="256" r:id="rId2"/>
+    <p:sldId id="257" r:id="rId3"/>
+    <p:sldId id="258" r:id="rId4"/>
+    <p:sldId id="259" r:id="rId5"/>
+    <p:sldId id="260" r:id="rId6"/>
+    <p:sldId id="261" r:id="rId7"/>
+    <p:sldId id="262" r:id="rId8"/>
+    <p:sldId id="263" r:id="rId9"/>
+    <p:sldId id="264" r:id="rId10"/>
+    <p:sldId id="265" r:id="rId11"/>
+    <p:sldId id="266" r:id="rId12"/>
+    <p:sldId id="267" r:id="rId13"/>
+    <p:sldId id="268" r:id="rId14"/>
+    <p:sldId id="269" r:id="rId15"/>
+    <p:sldId id="270" r:id="rId16"/>
+    <p:sldId id="271" r:id="rId17"/>
+    <p:sldId id="272" r:id="rId18"/>
+    <p:sldId id="273" r:id="rId19"/>
+    <p:sldId id="274" r:id="rId20"/>
   </p:sldIdLst>
-  <p:sldSz cx="12191695" cy="6858000" type="screen4x3"/>
+  <p:sldSz cx="12192000" cy="6858000"/>
   <p:notesSz cx="6858000" cy="9144000"/>
   <p:defaultTextStyle>
     <a:defPPr>
@@ -122,7 +122,31 @@
       </a:defRPr>
     </a:lvl9pPr>
   </p:defaultTextStyle>
+  <p:extLst>
+    <p:ext uri="{EFAFB233-063F-42B5-8137-9DF3F51BA10A}">
+      <p15:sldGuideLst xmlns:p15="http://schemas.microsoft.com/office/powerpoint/2012/main">
+        <p15:guide id="1" orient="horz" pos="2160">
+          <p15:clr>
+            <a:srgbClr val="A4A3A4"/>
+          </p15:clr>
+        </p15:guide>
+        <p15:guide id="2" pos="2880">
+          <p15:clr>
+            <a:srgbClr val="A4A3A4"/>
+          </p15:clr>
+        </p15:guide>
+      </p15:sldGuideLst>
+    </p:ext>
+  </p:extLst>
 </p:presentation>
+</file>
+
+<file path=ppt/revisionInfo.xml><?xml version="1.0" encoding="utf-8"?>
+<p1510:revInfo xmlns:a="http://schemas.openxmlformats.org/drawingml/2006/main" xmlns:r="http://schemas.openxmlformats.org/officeDocument/2006/relationships" xmlns:p1510="http://schemas.microsoft.com/office/powerpoint/2015/10/main">
+  <p1510:revLst>
+    <p1510:client id="{00000000-0000-0000-0000-000000000000}" v="59" dt="2026-09-14T11:39:31.028"/>
+  </p1510:revLst>
+</p1510:revInfo>
 </file>
 
 <file path=ppt/slideLayouts/slideLayout1.xml><?xml version="1.0" encoding="utf-8"?>
@@ -163,10 +187,9 @@
           <a:lstStyle/>
           <a:p>
             <a:r>
-              <a:rPr lang="en-US" smtClean="0"/>
+              <a:rPr lang="en-US"/>
               <a:t>Click to edit Master title style</a:t>
             </a:r>
-            <a:endParaRPr lang="en-US"/>
           </a:p>
         </p:txBody>
       </p:sp>
@@ -282,10 +305,9 @@
           </a:lstStyle>
           <a:p>
             <a:r>
-              <a:rPr lang="en-US" smtClean="0"/>
+              <a:rPr lang="en-US"/>
               <a:t>Click to edit Master subtitle style</a:t>
             </a:r>
-            <a:endParaRPr lang="en-US"/>
           </a:p>
         </p:txBody>
       </p:sp>
@@ -306,7 +328,7 @@
           <a:p>
             <a:fld id="{5BCAD085-E8A6-8845-BD4E-CB4CCA059FC4}" type="datetimeFigureOut">
               <a:rPr lang="en-US" smtClean="0"/>
-              <a:t>1/27/13</a:t>
+              <a:t>9/14/2026</a:t>
             </a:fld>
             <a:endParaRPr lang="en-US"/>
           </a:p>
@@ -400,10 +422,9 @@
           <a:lstStyle/>
           <a:p>
             <a:r>
-              <a:rPr lang="en-US" smtClean="0"/>
+              <a:rPr lang="en-US"/>
               <a:t>Click to edit Master title style</a:t>
             </a:r>
-            <a:endParaRPr lang="en-US"/>
           </a:p>
         </p:txBody>
       </p:sp>
@@ -424,38 +445,37 @@
           <a:p>
             <a:pPr lvl="0"/>
             <a:r>
-              <a:rPr lang="en-US" smtClean="0"/>
+              <a:rPr lang="en-US"/>
               <a:t>Click to edit Master text styles</a:t>
             </a:r>
           </a:p>
           <a:p>
             <a:pPr lvl="1"/>
             <a:r>
-              <a:rPr lang="en-US" smtClean="0"/>
+              <a:rPr lang="en-US"/>
               <a:t>Second level</a:t>
             </a:r>
           </a:p>
           <a:p>
             <a:pPr lvl="2"/>
             <a:r>
-              <a:rPr lang="en-US" smtClean="0"/>
+              <a:rPr lang="en-US"/>
               <a:t>Third level</a:t>
             </a:r>
           </a:p>
           <a:p>
             <a:pPr lvl="3"/>
             <a:r>
-              <a:rPr lang="en-US" smtClean="0"/>
+              <a:rPr lang="en-US"/>
               <a:t>Fourth level</a:t>
             </a:r>
           </a:p>
           <a:p>
             <a:pPr lvl="4"/>
             <a:r>
-              <a:rPr lang="en-US" smtClean="0"/>
+              <a:rPr lang="en-US"/>
               <a:t>Fifth level</a:t>
             </a:r>
-            <a:endParaRPr lang="en-US"/>
           </a:p>
         </p:txBody>
       </p:sp>
@@ -476,7 +496,7 @@
           <a:p>
             <a:fld id="{5BCAD085-E8A6-8845-BD4E-CB4CCA059FC4}" type="datetimeFigureOut">
               <a:rPr lang="en-US" smtClean="0"/>
-              <a:t>1/27/13</a:t>
+              <a:t>9/14/2026</a:t>
             </a:fld>
             <a:endParaRPr lang="en-US"/>
           </a:p>
@@ -575,10 +595,9 @@
           <a:lstStyle/>
           <a:p>
             <a:r>
-              <a:rPr lang="en-US" smtClean="0"/>
+              <a:rPr lang="en-US"/>
               <a:t>Click to edit Master title style</a:t>
             </a:r>
-            <a:endParaRPr lang="en-US"/>
           </a:p>
         </p:txBody>
       </p:sp>
@@ -604,38 +623,37 @@
           <a:p>
             <a:pPr lvl="0"/>
             <a:r>
-              <a:rPr lang="en-US" smtClean="0"/>
+              <a:rPr lang="en-US"/>
               <a:t>Click to edit Master text styles</a:t>
             </a:r>
           </a:p>
           <a:p>
             <a:pPr lvl="1"/>
             <a:r>
-              <a:rPr lang="en-US" smtClean="0"/>
+              <a:rPr lang="en-US"/>
               <a:t>Second level</a:t>
             </a:r>
           </a:p>
           <a:p>
             <a:pPr lvl="2"/>
             <a:r>
-              <a:rPr lang="en-US" smtClean="0"/>
+              <a:rPr lang="en-US"/>
               <a:t>Third level</a:t>
             </a:r>
           </a:p>
           <a:p>
             <a:pPr lvl="3"/>
             <a:r>
-              <a:rPr lang="en-US" smtClean="0"/>
+              <a:rPr lang="en-US"/>
               <a:t>Fourth level</a:t>
             </a:r>
           </a:p>
           <a:p>
             <a:pPr lvl="4"/>
             <a:r>
-              <a:rPr lang="en-US" smtClean="0"/>
+              <a:rPr lang="en-US"/>
               <a:t>Fifth level</a:t>
             </a:r>
-            <a:endParaRPr lang="en-US"/>
           </a:p>
         </p:txBody>
       </p:sp>
@@ -656,7 +674,7 @@
           <a:p>
             <a:fld id="{5BCAD085-E8A6-8845-BD4E-CB4CCA059FC4}" type="datetimeFigureOut">
               <a:rPr lang="en-US" smtClean="0"/>
-              <a:t>1/27/13</a:t>
+              <a:t>9/14/2026</a:t>
             </a:fld>
             <a:endParaRPr lang="en-US"/>
           </a:p>
@@ -750,10 +768,9 @@
           <a:lstStyle/>
           <a:p>
             <a:r>
-              <a:rPr lang="en-US" smtClean="0"/>
+              <a:rPr lang="en-US"/>
               <a:t>Click to edit Master title style</a:t>
             </a:r>
-            <a:endParaRPr lang="en-US"/>
           </a:p>
         </p:txBody>
       </p:sp>
@@ -774,38 +791,37 @@
           <a:p>
             <a:pPr lvl="0"/>
             <a:r>
-              <a:rPr lang="en-US" smtClean="0"/>
+              <a:rPr lang="en-US"/>
               <a:t>Click to edit Master text styles</a:t>
             </a:r>
           </a:p>
           <a:p>
             <a:pPr lvl="1"/>
             <a:r>
-              <a:rPr lang="en-US" smtClean="0"/>
+              <a:rPr lang="en-US"/>
               <a:t>Second level</a:t>
             </a:r>
           </a:p>
           <a:p>
             <a:pPr lvl="2"/>
             <a:r>
-              <a:rPr lang="en-US" smtClean="0"/>
+              <a:rPr lang="en-US"/>
               <a:t>Third level</a:t>
             </a:r>
           </a:p>
           <a:p>
             <a:pPr lvl="3"/>
             <a:r>
-              <a:rPr lang="en-US" smtClean="0"/>
+              <a:rPr lang="en-US"/>
               <a:t>Fourth level</a:t>
             </a:r>
           </a:p>
           <a:p>
             <a:pPr lvl="4"/>
             <a:r>
-              <a:rPr lang="en-US" smtClean="0"/>
+              <a:rPr lang="en-US"/>
               <a:t>Fifth level</a:t>
             </a:r>
-            <a:endParaRPr lang="en-US"/>
           </a:p>
         </p:txBody>
       </p:sp>
@@ -826,7 +842,7 @@
           <a:p>
             <a:fld id="{5BCAD085-E8A6-8845-BD4E-CB4CCA059FC4}" type="datetimeFigureOut">
               <a:rPr lang="en-US" smtClean="0"/>
-              <a:t>1/27/13</a:t>
+              <a:t>9/14/2026</a:t>
             </a:fld>
             <a:endParaRPr lang="en-US"/>
           </a:p>
@@ -929,10 +945,9 @@
           </a:lstStyle>
           <a:p>
             <a:r>
-              <a:rPr lang="en-US" smtClean="0"/>
+              <a:rPr lang="en-US"/>
               <a:t>Click to edit Master title style</a:t>
             </a:r>
-            <a:endParaRPr lang="en-US"/>
           </a:p>
         </p:txBody>
       </p:sp>
@@ -1049,7 +1064,7 @@
           <a:p>
             <a:pPr lvl="0"/>
             <a:r>
-              <a:rPr lang="en-US" smtClean="0"/>
+              <a:rPr lang="en-US"/>
               <a:t>Click to edit Master text styles</a:t>
             </a:r>
           </a:p>
@@ -1072,7 +1087,7 @@
           <a:p>
             <a:fld id="{5BCAD085-E8A6-8845-BD4E-CB4CCA059FC4}" type="datetimeFigureOut">
               <a:rPr lang="en-US" smtClean="0"/>
-              <a:t>1/27/13</a:t>
+              <a:t>9/14/2026</a:t>
             </a:fld>
             <a:endParaRPr lang="en-US"/>
           </a:p>
@@ -1166,10 +1181,9 @@
           <a:lstStyle/>
           <a:p>
             <a:r>
-              <a:rPr lang="en-US" smtClean="0"/>
+              <a:rPr lang="en-US"/>
               <a:t>Click to edit Master title style</a:t>
             </a:r>
-            <a:endParaRPr lang="en-US"/>
           </a:p>
         </p:txBody>
       </p:sp>
@@ -1223,38 +1237,37 @@
           <a:p>
             <a:pPr lvl="0"/>
             <a:r>
-              <a:rPr lang="en-US" smtClean="0"/>
+              <a:rPr lang="en-US"/>
               <a:t>Click to edit Master text styles</a:t>
             </a:r>
           </a:p>
           <a:p>
             <a:pPr lvl="1"/>
             <a:r>
-              <a:rPr lang="en-US" smtClean="0"/>
+              <a:rPr lang="en-US"/>
               <a:t>Second level</a:t>
             </a:r>
           </a:p>
           <a:p>
             <a:pPr lvl="2"/>
             <a:r>
-              <a:rPr lang="en-US" smtClean="0"/>
+              <a:rPr lang="en-US"/>
               <a:t>Third level</a:t>
             </a:r>
           </a:p>
           <a:p>
             <a:pPr lvl="3"/>
             <a:r>
-              <a:rPr lang="en-US" smtClean="0"/>
+              <a:rPr lang="en-US"/>
               <a:t>Fourth level</a:t>
             </a:r>
           </a:p>
           <a:p>
             <a:pPr lvl="4"/>
             <a:r>
-              <a:rPr lang="en-US" smtClean="0"/>
+              <a:rPr lang="en-US"/>
               <a:t>Fifth level</a:t>
             </a:r>
-            <a:endParaRPr lang="en-US"/>
           </a:p>
         </p:txBody>
       </p:sp>
@@ -1308,38 +1321,37 @@
           <a:p>
             <a:pPr lvl="0"/>
             <a:r>
-              <a:rPr lang="en-US" smtClean="0"/>
+              <a:rPr lang="en-US"/>
               <a:t>Click to edit Master text styles</a:t>
             </a:r>
           </a:p>
           <a:p>
             <a:pPr lvl="1"/>
             <a:r>
-              <a:rPr lang="en-US" smtClean="0"/>
+              <a:rPr lang="en-US"/>
               <a:t>Second level</a:t>
             </a:r>
           </a:p>
           <a:p>
             <a:pPr lvl="2"/>
             <a:r>
-              <a:rPr lang="en-US" smtClean="0"/>
+              <a:rPr lang="en-US"/>
               <a:t>Third level</a:t>
             </a:r>
           </a:p>
           <a:p>
             <a:pPr lvl="3"/>
             <a:r>
-              <a:rPr lang="en-US" smtClean="0"/>
+              <a:rPr lang="en-US"/>
               <a:t>Fourth level</a:t>
             </a:r>
           </a:p>
           <a:p>
             <a:pPr lvl="4"/>
             <a:r>
-              <a:rPr lang="en-US" smtClean="0"/>
+              <a:rPr lang="en-US"/>
               <a:t>Fifth level</a:t>
             </a:r>
-            <a:endParaRPr lang="en-US"/>
           </a:p>
         </p:txBody>
       </p:sp>
@@ -1360,7 +1372,7 @@
           <a:p>
             <a:fld id="{5BCAD085-E8A6-8845-BD4E-CB4CCA059FC4}" type="datetimeFigureOut">
               <a:rPr lang="en-US" smtClean="0"/>
-              <a:t>1/27/13</a:t>
+              <a:t>9/14/2026</a:t>
             </a:fld>
             <a:endParaRPr lang="en-US"/>
           </a:p>
@@ -1458,10 +1470,9 @@
           </a:lstStyle>
           <a:p>
             <a:r>
-              <a:rPr lang="en-US" smtClean="0"/>
+              <a:rPr lang="en-US"/>
               <a:t>Click to edit Master title style</a:t>
             </a:r>
-            <a:endParaRPr lang="en-US"/>
           </a:p>
         </p:txBody>
       </p:sp>
@@ -1524,7 +1535,7 @@
           <a:p>
             <a:pPr lvl="0"/>
             <a:r>
-              <a:rPr lang="en-US" smtClean="0"/>
+              <a:rPr lang="en-US"/>
               <a:t>Click to edit Master text styles</a:t>
             </a:r>
           </a:p>
@@ -1580,38 +1591,37 @@
           <a:p>
             <a:pPr lvl="0"/>
             <a:r>
-              <a:rPr lang="en-US" smtClean="0"/>
+              <a:rPr lang="en-US"/>
               <a:t>Click to edit Master text styles</a:t>
             </a:r>
           </a:p>
           <a:p>
             <a:pPr lvl="1"/>
             <a:r>
-              <a:rPr lang="en-US" smtClean="0"/>
+              <a:rPr lang="en-US"/>
               <a:t>Second level</a:t>
             </a:r>
           </a:p>
           <a:p>
             <a:pPr lvl="2"/>
             <a:r>
-              <a:rPr lang="en-US" smtClean="0"/>
+              <a:rPr lang="en-US"/>
               <a:t>Third level</a:t>
             </a:r>
           </a:p>
           <a:p>
             <a:pPr lvl="3"/>
             <a:r>
-              <a:rPr lang="en-US" smtClean="0"/>
+              <a:rPr lang="en-US"/>
               <a:t>Fourth level</a:t>
             </a:r>
           </a:p>
           <a:p>
             <a:pPr lvl="4"/>
             <a:r>
-              <a:rPr lang="en-US" smtClean="0"/>
+              <a:rPr lang="en-US"/>
               <a:t>Fifth level</a:t>
             </a:r>
-            <a:endParaRPr lang="en-US"/>
           </a:p>
         </p:txBody>
       </p:sp>
@@ -1674,7 +1684,7 @@
           <a:p>
             <a:pPr lvl="0"/>
             <a:r>
-              <a:rPr lang="en-US" smtClean="0"/>
+              <a:rPr lang="en-US"/>
               <a:t>Click to edit Master text styles</a:t>
             </a:r>
           </a:p>
@@ -1730,38 +1740,37 @@
           <a:p>
             <a:pPr lvl="0"/>
             <a:r>
-              <a:rPr lang="en-US" smtClean="0"/>
+              <a:rPr lang="en-US"/>
               <a:t>Click to edit Master text styles</a:t>
             </a:r>
           </a:p>
           <a:p>
             <a:pPr lvl="1"/>
             <a:r>
-              <a:rPr lang="en-US" smtClean="0"/>
+              <a:rPr lang="en-US"/>
               <a:t>Second level</a:t>
             </a:r>
           </a:p>
           <a:p>
             <a:pPr lvl="2"/>
             <a:r>
-              <a:rPr lang="en-US" smtClean="0"/>
+              <a:rPr lang="en-US"/>
               <a:t>Third level</a:t>
             </a:r>
           </a:p>
           <a:p>
             <a:pPr lvl="3"/>
             <a:r>
-              <a:rPr lang="en-US" smtClean="0"/>
+              <a:rPr lang="en-US"/>
               <a:t>Fourth level</a:t>
             </a:r>
           </a:p>
           <a:p>
             <a:pPr lvl="4"/>
             <a:r>
-              <a:rPr lang="en-US" smtClean="0"/>
+              <a:rPr lang="en-US"/>
               <a:t>Fifth level</a:t>
             </a:r>
-            <a:endParaRPr lang="en-US"/>
           </a:p>
         </p:txBody>
       </p:sp>
@@ -1782,7 +1791,7 @@
           <a:p>
             <a:fld id="{5BCAD085-E8A6-8845-BD4E-CB4CCA059FC4}" type="datetimeFigureOut">
               <a:rPr lang="en-US" smtClean="0"/>
-              <a:t>1/27/13</a:t>
+              <a:t>9/14/2026</a:t>
             </a:fld>
             <a:endParaRPr lang="en-US"/>
           </a:p>
@@ -1876,10 +1885,9 @@
           <a:lstStyle/>
           <a:p>
             <a:r>
-              <a:rPr lang="en-US" smtClean="0"/>
+              <a:rPr lang="en-US"/>
               <a:t>Click to edit Master title style</a:t>
             </a:r>
-            <a:endParaRPr lang="en-US"/>
           </a:p>
         </p:txBody>
       </p:sp>
@@ -1900,7 +1908,7 @@
           <a:p>
             <a:fld id="{5BCAD085-E8A6-8845-BD4E-CB4CCA059FC4}" type="datetimeFigureOut">
               <a:rPr lang="en-US" smtClean="0"/>
-              <a:t>1/27/13</a:t>
+              <a:t>9/14/2026</a:t>
             </a:fld>
             <a:endParaRPr lang="en-US"/>
           </a:p>
@@ -1995,7 +2003,7 @@
           <a:p>
             <a:fld id="{5BCAD085-E8A6-8845-BD4E-CB4CCA059FC4}" type="datetimeFigureOut">
               <a:rPr lang="en-US" smtClean="0"/>
-              <a:t>1/27/13</a:t>
+              <a:t>9/14/2026</a:t>
             </a:fld>
             <a:endParaRPr lang="en-US"/>
           </a:p>
@@ -2098,10 +2106,9 @@
           </a:lstStyle>
           <a:p>
             <a:r>
-              <a:rPr lang="en-US" smtClean="0"/>
+              <a:rPr lang="en-US"/>
               <a:t>Click to edit Master title style</a:t>
             </a:r>
-            <a:endParaRPr lang="en-US"/>
           </a:p>
         </p:txBody>
       </p:sp>
@@ -2155,38 +2162,37 @@
           <a:p>
             <a:pPr lvl="0"/>
             <a:r>
-              <a:rPr lang="en-US" smtClean="0"/>
+              <a:rPr lang="en-US"/>
               <a:t>Click to edit Master text styles</a:t>
             </a:r>
           </a:p>
           <a:p>
             <a:pPr lvl="1"/>
             <a:r>
-              <a:rPr lang="en-US" smtClean="0"/>
+              <a:rPr lang="en-US"/>
               <a:t>Second level</a:t>
             </a:r>
           </a:p>
           <a:p>
             <a:pPr lvl="2"/>
             <a:r>
-              <a:rPr lang="en-US" smtClean="0"/>
+              <a:rPr lang="en-US"/>
               <a:t>Third level</a:t>
             </a:r>
           </a:p>
           <a:p>
             <a:pPr lvl="3"/>
             <a:r>
-              <a:rPr lang="en-US" smtClean="0"/>
+              <a:rPr lang="en-US"/>
               <a:t>Fourth level</a:t>
             </a:r>
           </a:p>
           <a:p>
             <a:pPr lvl="4"/>
             <a:r>
-              <a:rPr lang="en-US" smtClean="0"/>
+              <a:rPr lang="en-US"/>
               <a:t>Fifth level</a:t>
             </a:r>
-            <a:endParaRPr lang="en-US"/>
           </a:p>
         </p:txBody>
       </p:sp>
@@ -2249,7 +2255,7 @@
           <a:p>
             <a:pPr lvl="0"/>
             <a:r>
-              <a:rPr lang="en-US" smtClean="0"/>
+              <a:rPr lang="en-US"/>
               <a:t>Click to edit Master text styles</a:t>
             </a:r>
           </a:p>
@@ -2272,7 +2278,7 @@
           <a:p>
             <a:fld id="{5BCAD085-E8A6-8845-BD4E-CB4CCA059FC4}" type="datetimeFigureOut">
               <a:rPr lang="en-US" smtClean="0"/>
-              <a:t>1/27/13</a:t>
+              <a:t>9/14/2026</a:t>
             </a:fld>
             <a:endParaRPr lang="en-US"/>
           </a:p>
@@ -2375,10 +2381,9 @@
           </a:lstStyle>
           <a:p>
             <a:r>
-              <a:rPr lang="en-US" smtClean="0"/>
+              <a:rPr lang="en-US"/>
               <a:t>Click to edit Master title style</a:t>
             </a:r>
-            <a:endParaRPr lang="en-US"/>
           </a:p>
         </p:txBody>
       </p:sp>
@@ -2502,7 +2507,7 @@
           <a:p>
             <a:pPr lvl="0"/>
             <a:r>
-              <a:rPr lang="en-US" smtClean="0"/>
+              <a:rPr lang="en-US"/>
               <a:t>Click to edit Master text styles</a:t>
             </a:r>
           </a:p>
@@ -2525,7 +2530,7 @@
           <a:p>
             <a:fld id="{5BCAD085-E8A6-8845-BD4E-CB4CCA059FC4}" type="datetimeFigureOut">
               <a:rPr lang="en-US" smtClean="0"/>
-              <a:t>1/27/13</a:t>
+              <a:t>9/14/2026</a:t>
             </a:fld>
             <a:endParaRPr lang="en-US"/>
           </a:p>
@@ -2634,10 +2639,9 @@
           <a:lstStyle/>
           <a:p>
             <a:r>
-              <a:rPr lang="en-US" smtClean="0"/>
+              <a:rPr lang="en-US"/>
               <a:t>Click to edit Master title style</a:t>
             </a:r>
-            <a:endParaRPr lang="en-US"/>
           </a:p>
         </p:txBody>
       </p:sp>
@@ -2668,38 +2672,37 @@
           <a:p>
             <a:pPr lvl="0"/>
             <a:r>
-              <a:rPr lang="en-US" smtClean="0"/>
+              <a:rPr lang="en-US"/>
               <a:t>Click to edit Master text styles</a:t>
             </a:r>
           </a:p>
           <a:p>
             <a:pPr lvl="1"/>
             <a:r>
-              <a:rPr lang="en-US" smtClean="0"/>
+              <a:rPr lang="en-US"/>
               <a:t>Second level</a:t>
             </a:r>
           </a:p>
           <a:p>
             <a:pPr lvl="2"/>
             <a:r>
-              <a:rPr lang="en-US" smtClean="0"/>
+              <a:rPr lang="en-US"/>
               <a:t>Third level</a:t>
             </a:r>
           </a:p>
           <a:p>
             <a:pPr lvl="3"/>
             <a:r>
-              <a:rPr lang="en-US" smtClean="0"/>
+              <a:rPr lang="en-US"/>
               <a:t>Fourth level</a:t>
             </a:r>
           </a:p>
           <a:p>
             <a:pPr lvl="4"/>
             <a:r>
-              <a:rPr lang="en-US" smtClean="0"/>
+              <a:rPr lang="en-US"/>
               <a:t>Fifth level</a:t>
             </a:r>
-            <a:endParaRPr lang="en-US"/>
           </a:p>
         </p:txBody>
       </p:sp>
@@ -2738,7 +2741,7 @@
           <a:p>
             <a:fld id="{5BCAD085-E8A6-8845-BD4E-CB4CCA059FC4}" type="datetimeFigureOut">
               <a:rPr lang="en-US" smtClean="0"/>
-              <a:t>1/27/13</a:t>
+              <a:t>9/14/2026</a:t>
             </a:fld>
             <a:endParaRPr lang="en-US"/>
           </a:p>
@@ -3097,7 +3100,7 @@
 </file>
 
 <file path=ppt/slides/slide1.xml><?xml version="1.0" encoding="utf-8"?>
-<p:sld xmlns:a="http://schemas.openxmlformats.org/drawingml/2006/main" xmlns:p="http://schemas.openxmlformats.org/presentationml/2006/main" xmlns:r="http://schemas.openxmlformats.org/officeDocument/2006/relationships">
+<p:sld xmlns:a="http://schemas.openxmlformats.org/drawingml/2006/main" xmlns:r="http://schemas.openxmlformats.org/officeDocument/2006/relationships" xmlns:p="http://schemas.openxmlformats.org/presentationml/2006/main">
   <p:cSld>
     <p:spTree>
       <p:nvGrpSpPr>
@@ -3105,7 +3108,14 @@
         <p:cNvGrpSpPr/>
         <p:nvPr/>
       </p:nvGrpSpPr>
-      <p:grpSpPr/>
+      <p:grpSpPr>
+        <a:xfrm>
+          <a:off x="0" y="0"/>
+          <a:ext cx="0" cy="0"/>
+          <a:chOff x="0" y="0"/>
+          <a:chExt cx="0" cy="0"/>
+        </a:xfrm>
+      </p:grpSpPr>
       <p:sp>
         <p:nvSpPr>
           <p:cNvPr id="2" name="Rectangle 1"/>
@@ -3146,6 +3156,7 @@
           <a:lstStyle/>
           <a:p>
             <a:pPr algn="ctr"/>
+            <a:endParaRPr/>
           </a:p>
         </p:txBody>
       </p:sp>
@@ -3189,6 +3200,7 @@
           <a:lstStyle/>
           <a:p>
             <a:pPr algn="ctr"/>
+            <a:endParaRPr/>
           </a:p>
         </p:txBody>
       </p:sp>
@@ -3232,6 +3244,7 @@
           <a:lstStyle/>
           <a:p>
             <a:pPr algn="ctr"/>
+            <a:endParaRPr/>
           </a:p>
         </p:txBody>
       </p:sp>
@@ -3275,6 +3288,7 @@
           <a:lstStyle/>
           <a:p>
             <a:pPr algn="ctr"/>
+            <a:endParaRPr/>
           </a:p>
         </p:txBody>
       </p:sp>
@@ -3318,6 +3332,7 @@
           <a:lstStyle/>
           <a:p>
             <a:pPr algn="ctr"/>
+            <a:endParaRPr/>
           </a:p>
         </p:txBody>
       </p:sp>
@@ -3361,6 +3376,7 @@
           <a:lstStyle/>
           <a:p>
             <a:pPr algn="ctr"/>
+            <a:endParaRPr/>
           </a:p>
         </p:txBody>
       </p:sp>
@@ -3404,6 +3420,7 @@
           <a:lstStyle/>
           <a:p>
             <a:pPr algn="ctr"/>
+            <a:endParaRPr/>
           </a:p>
         </p:txBody>
       </p:sp>
@@ -3555,6 +3572,7 @@
           <a:lstStyle/>
           <a:p>
             <a:pPr algn="ctr"/>
+            <a:endParaRPr/>
           </a:p>
         </p:txBody>
       </p:sp>
@@ -3670,6 +3688,7 @@
           <a:lstStyle/>
           <a:p>
             <a:pPr algn="ctr"/>
+            <a:endParaRPr/>
           </a:p>
         </p:txBody>
       </p:sp>
@@ -3785,6 +3804,7 @@
           <a:lstStyle/>
           <a:p>
             <a:pPr algn="ctr"/>
+            <a:endParaRPr/>
           </a:p>
         </p:txBody>
       </p:sp>
@@ -3900,6 +3920,7 @@
           <a:lstStyle/>
           <a:p>
             <a:pPr algn="ctr"/>
+            <a:endParaRPr/>
           </a:p>
         </p:txBody>
       </p:sp>
@@ -4015,6 +4036,7 @@
           <a:lstStyle/>
           <a:p>
             <a:pPr algn="ctr"/>
+            <a:endParaRPr/>
           </a:p>
         </p:txBody>
       </p:sp>
@@ -4049,41 +4071,6 @@
                 <a:latin typeface="Aptos"/>
               </a:rPr>
               <a:t>ML</a:t>
-            </a:r>
-          </a:p>
-        </p:txBody>
-      </p:sp>
-      <p:sp>
-        <p:nvSpPr>
-          <p:cNvPr id="26" name="TextBox 25"/>
-          <p:cNvSpPr txBox="1"/>
-          <p:nvPr/>
-        </p:nvSpPr>
-        <p:spPr>
-          <a:xfrm>
-            <a:off x="658368" y="5257800"/>
-            <a:ext cx="6858000" cy="365760"/>
-          </a:xfrm>
-          <a:prstGeom prst="rect">
-            <a:avLst/>
-          </a:prstGeom>
-          <a:noFill/>
-        </p:spPr>
-        <p:txBody>
-          <a:bodyPr wrap="square" anchor="t">
-            <a:spAutoFit/>
-          </a:bodyPr>
-          <a:lstStyle/>
-          <a:p>
-            <a:pPr algn="l"/>
-            <a:r>
-              <a:rPr sz="1400" b="1">
-                <a:solidFill>
-                  <a:srgbClr val="FFFFFF"/>
-                </a:solidFill>
-                <a:latin typeface="Aptos"/>
-              </a:rPr>
-              <a:t>Customer Pitch + Technical Architecture</a:t>
             </a:r>
           </a:p>
         </p:txBody>
@@ -4132,7 +4119,7 @@
 </file>
 
 <file path=ppt/slides/slide10.xml><?xml version="1.0" encoding="utf-8"?>
-<p:sld xmlns:a="http://schemas.openxmlformats.org/drawingml/2006/main" xmlns:p="http://schemas.openxmlformats.org/presentationml/2006/main" xmlns:r="http://schemas.openxmlformats.org/officeDocument/2006/relationships">
+<p:sld xmlns:a="http://schemas.openxmlformats.org/drawingml/2006/main" xmlns:r="http://schemas.openxmlformats.org/officeDocument/2006/relationships" xmlns:p="http://schemas.openxmlformats.org/presentationml/2006/main">
   <p:cSld>
     <p:spTree>
       <p:nvGrpSpPr>
@@ -4140,7 +4127,14 @@
         <p:cNvGrpSpPr/>
         <p:nvPr/>
       </p:nvGrpSpPr>
-      <p:grpSpPr/>
+      <p:grpSpPr>
+        <a:xfrm>
+          <a:off x="0" y="0"/>
+          <a:ext cx="0" cy="0"/>
+          <a:chOff x="0" y="0"/>
+          <a:chExt cx="0" cy="0"/>
+        </a:xfrm>
+      </p:grpSpPr>
       <p:sp>
         <p:nvSpPr>
           <p:cNvPr id="2" name="Rectangle 1"/>
@@ -4181,6 +4175,7 @@
           <a:lstStyle/>
           <a:p>
             <a:pPr algn="ctr"/>
+            <a:endParaRPr/>
           </a:p>
         </p:txBody>
       </p:sp>
@@ -4248,40 +4243,6 @@
                 <a:latin typeface="Aptos"/>
               </a:rPr>
               <a:t>Frontend Experience — Churn Prediction</a:t>
-            </a:r>
-          </a:p>
-        </p:txBody>
-      </p:sp>
-      <p:sp>
-        <p:nvSpPr>
-          <p:cNvPr id="5" name="TextBox 4"/>
-          <p:cNvSpPr txBox="1"/>
-          <p:nvPr/>
-        </p:nvSpPr>
-        <p:spPr>
-          <a:xfrm>
-            <a:off x="521207" y="1143000"/>
-            <a:ext cx="10789920" cy="365760"/>
-          </a:xfrm>
-          <a:prstGeom prst="rect">
-            <a:avLst/>
-          </a:prstGeom>
-          <a:noFill/>
-        </p:spPr>
-        <p:txBody>
-          <a:bodyPr wrap="none">
-            <a:spAutoFit/>
-          </a:bodyPr>
-          <a:lstStyle/>
-          <a:p>
-            <a:r>
-              <a:rPr sz="1100">
-                <a:solidFill>
-                  <a:srgbClr val="627081"/>
-                </a:solidFill>
-                <a:latin typeface="Aptos"/>
-              </a:rPr>
-              <a:t>Placeholder for the form-to-risk-score flow.</a:t>
             </a:r>
           </a:p>
         </p:txBody>
@@ -4326,6 +4287,7 @@
           <a:lstStyle/>
           <a:p>
             <a:pPr algn="ctr"/>
+            <a:endParaRPr/>
           </a:p>
         </p:txBody>
       </p:sp>
@@ -4394,210 +4356,6 @@
                 <a:latin typeface="Aptos"/>
               </a:rPr>
               <a:t>10</a:t>
-            </a:r>
-          </a:p>
-        </p:txBody>
-      </p:sp>
-      <p:sp>
-        <p:nvSpPr>
-          <p:cNvPr id="9" name="Rounded Rectangle 8"/>
-          <p:cNvSpPr/>
-          <p:nvPr/>
-        </p:nvSpPr>
-        <p:spPr>
-          <a:xfrm>
-            <a:off x="594360" y="1874519"/>
-            <a:ext cx="7406640" cy="4069080"/>
-          </a:xfrm>
-          <a:prstGeom prst="roundRect">
-            <a:avLst/>
-          </a:prstGeom>
-          <a:solidFill>
-            <a:srgbClr val="EEF2F7"/>
-          </a:solidFill>
-          <a:ln w="19050">
-            <a:solidFill>
-              <a:srgbClr val="2A69B4"/>
-            </a:solidFill>
-            <a:prstDash val="dash"/>
-          </a:ln>
-        </p:spPr>
-        <p:style>
-          <a:lnRef idx="1">
-            <a:schemeClr val="accent1"/>
-          </a:lnRef>
-          <a:fillRef idx="3">
-            <a:schemeClr val="accent1"/>
-          </a:fillRef>
-          <a:effectRef idx="2">
-            <a:schemeClr val="accent1"/>
-          </a:effectRef>
-          <a:fontRef idx="minor">
-            <a:schemeClr val="lt1"/>
-          </a:fontRef>
-        </p:style>
-        <p:txBody>
-          <a:bodyPr rtlCol="0" anchor="ctr"/>
-          <a:lstStyle/>
-          <a:p>
-            <a:pPr algn="ctr"/>
-          </a:p>
-        </p:txBody>
-      </p:sp>
-      <p:sp>
-        <p:nvSpPr>
-          <p:cNvPr id="10" name="Rectangle 9"/>
-          <p:cNvSpPr/>
-          <p:nvPr/>
-        </p:nvSpPr>
-        <p:spPr>
-          <a:xfrm>
-            <a:off x="3886200" y="3451860"/>
-            <a:ext cx="822960" cy="658368"/>
-          </a:xfrm>
-          <a:prstGeom prst="rect">
-            <a:avLst/>
-          </a:prstGeom>
-          <a:solidFill>
-            <a:srgbClr val="FFFFFF"/>
-          </a:solidFill>
-          <a:ln>
-            <a:solidFill>
-              <a:srgbClr val="2A69B4"/>
-            </a:solidFill>
-          </a:ln>
-        </p:spPr>
-        <p:style>
-          <a:lnRef idx="1">
-            <a:schemeClr val="accent1"/>
-          </a:lnRef>
-          <a:fillRef idx="3">
-            <a:schemeClr val="accent1"/>
-          </a:fillRef>
-          <a:effectRef idx="2">
-            <a:schemeClr val="accent1"/>
-          </a:effectRef>
-          <a:fontRef idx="minor">
-            <a:schemeClr val="lt1"/>
-          </a:fontRef>
-        </p:style>
-        <p:txBody>
-          <a:bodyPr rtlCol="0" anchor="ctr"/>
-          <a:lstStyle/>
-          <a:p>
-            <a:pPr algn="ctr"/>
-          </a:p>
-        </p:txBody>
-      </p:sp>
-      <p:sp>
-        <p:nvSpPr>
-          <p:cNvPr id="11" name="Oval 10"/>
-          <p:cNvSpPr/>
-          <p:nvPr/>
-        </p:nvSpPr>
-        <p:spPr>
-          <a:xfrm>
-            <a:off x="4343400" y="3589020"/>
-            <a:ext cx="109728" cy="109728"/>
-          </a:xfrm>
-          <a:prstGeom prst="ellipse">
-            <a:avLst/>
-          </a:prstGeom>
-          <a:solidFill>
-            <a:srgbClr val="2A69B4"/>
-          </a:solidFill>
-          <a:ln>
-            <a:noFill/>
-          </a:ln>
-        </p:spPr>
-        <p:style>
-          <a:lnRef idx="1">
-            <a:schemeClr val="accent1"/>
-          </a:lnRef>
-          <a:fillRef idx="3">
-            <a:schemeClr val="accent1"/>
-          </a:fillRef>
-          <a:effectRef idx="2">
-            <a:schemeClr val="accent1"/>
-          </a:effectRef>
-          <a:fontRef idx="minor">
-            <a:schemeClr val="lt1"/>
-          </a:fontRef>
-        </p:style>
-        <p:txBody>
-          <a:bodyPr rtlCol="0" anchor="ctr"/>
-          <a:lstStyle/>
-          <a:p>
-            <a:pPr algn="ctr"/>
-          </a:p>
-        </p:txBody>
-      </p:sp>
-      <p:sp>
-        <p:nvSpPr>
-          <p:cNvPr id="12" name="TextBox 11"/>
-          <p:cNvSpPr txBox="1"/>
-          <p:nvPr/>
-        </p:nvSpPr>
-        <p:spPr>
-          <a:xfrm>
-            <a:off x="868680" y="4183380"/>
-            <a:ext cx="6858000" cy="320040"/>
-          </a:xfrm>
-          <a:prstGeom prst="rect">
-            <a:avLst/>
-          </a:prstGeom>
-          <a:noFill/>
-        </p:spPr>
-        <p:txBody>
-          <a:bodyPr wrap="square" anchor="t">
-            <a:spAutoFit/>
-          </a:bodyPr>
-          <a:lstStyle/>
-          <a:p>
-            <a:pPr algn="ctr"/>
-            <a:r>
-              <a:rPr sz="1500" b="1">
-                <a:solidFill>
-                  <a:srgbClr val="122B4C"/>
-                </a:solidFill>
-                <a:latin typeface="Aptos"/>
-              </a:rPr>
-              <a:t>PASTE CHURN PREDICTION SCREENSHOT HERE</a:t>
-            </a:r>
-          </a:p>
-        </p:txBody>
-      </p:sp>
-      <p:sp>
-        <p:nvSpPr>
-          <p:cNvPr id="13" name="TextBox 12"/>
-          <p:cNvSpPr txBox="1"/>
-          <p:nvPr/>
-        </p:nvSpPr>
-        <p:spPr>
-          <a:xfrm>
-            <a:off x="868680" y="4530852"/>
-            <a:ext cx="6858000" cy="274320"/>
-          </a:xfrm>
-          <a:prstGeom prst="rect">
-            <a:avLst/>
-          </a:prstGeom>
-          <a:noFill/>
-        </p:spPr>
-        <p:txBody>
-          <a:bodyPr wrap="square" anchor="t">
-            <a:spAutoFit/>
-          </a:bodyPr>
-          <a:lstStyle/>
-          <a:p>
-            <a:pPr algn="ctr"/>
-            <a:r>
-              <a:rPr sz="950" b="0">
-                <a:solidFill>
-                  <a:srgbClr val="627081"/>
-                </a:solidFill>
-                <a:latin typeface="Aptos"/>
-              </a:rPr>
-              <a:t>Replace with actual frontend screenshot</a:t>
             </a:r>
           </a:p>
         </p:txBody>
@@ -4644,6 +4402,7 @@
           <a:lstStyle/>
           <a:p>
             <a:pPr algn="ctr"/>
+            <a:endParaRPr/>
           </a:p>
         </p:txBody>
       </p:sp>
@@ -4687,6 +4446,7 @@
           <a:lstStyle/>
           <a:p>
             <a:pPr algn="ctr"/>
+            <a:endParaRPr/>
           </a:p>
         </p:txBody>
       </p:sp>
@@ -4802,6 +4562,7 @@
           <a:lstStyle/>
           <a:p>
             <a:pPr algn="ctr"/>
+            <a:endParaRPr/>
           </a:p>
         </p:txBody>
       </p:sp>
@@ -4845,6 +4606,7 @@
           <a:lstStyle/>
           <a:p>
             <a:pPr algn="ctr"/>
+            <a:endParaRPr/>
           </a:p>
         </p:txBody>
       </p:sp>
@@ -4960,6 +4722,7 @@
           <a:lstStyle/>
           <a:p>
             <a:pPr algn="ctr"/>
+            <a:endParaRPr/>
           </a:p>
         </p:txBody>
       </p:sp>
@@ -5003,6 +4766,7 @@
           <a:lstStyle/>
           <a:p>
             <a:pPr algn="ctr"/>
+            <a:endParaRPr/>
           </a:p>
         </p:txBody>
       </p:sp>
@@ -5076,6 +4840,36 @@
           </a:p>
         </p:txBody>
       </p:sp>
+      <p:pic>
+        <p:nvPicPr>
+          <p:cNvPr id="26" name="Picture 25">
+            <a:extLst>
+              <a:ext uri="{FF2B5EF4-FFF2-40B4-BE49-F238E27FC236}">
+                <a16:creationId xmlns:a16="http://schemas.microsoft.com/office/drawing/2014/main" id="{08067AEE-42B4-C975-9D4F-98C8FD72BA7B}"/>
+              </a:ext>
+            </a:extLst>
+          </p:cNvPr>
+          <p:cNvPicPr>
+            <a:picLocks noChangeAspect="1"/>
+          </p:cNvPicPr>
+          <p:nvPr/>
+        </p:nvPicPr>
+        <p:blipFill>
+          <a:blip r:embed="rId2"/>
+          <a:stretch>
+            <a:fillRect/>
+          </a:stretch>
+        </p:blipFill>
+        <p:spPr>
+          <a:xfrm>
+            <a:off x="981868" y="1737360"/>
+            <a:ext cx="5991545" cy="4612640"/>
+          </a:xfrm>
+          <a:prstGeom prst="rect">
+            <a:avLst/>
+          </a:prstGeom>
+        </p:spPr>
+      </p:pic>
     </p:spTree>
   </p:cSld>
   <p:clrMapOvr>
@@ -5085,7 +4879,7 @@
 </file>
 
 <file path=ppt/slides/slide11.xml><?xml version="1.0" encoding="utf-8"?>
-<p:sld xmlns:a="http://schemas.openxmlformats.org/drawingml/2006/main" xmlns:p="http://schemas.openxmlformats.org/presentationml/2006/main" xmlns:r="http://schemas.openxmlformats.org/officeDocument/2006/relationships">
+<p:sld xmlns:a="http://schemas.openxmlformats.org/drawingml/2006/main" xmlns:r="http://schemas.openxmlformats.org/officeDocument/2006/relationships" xmlns:p="http://schemas.openxmlformats.org/presentationml/2006/main">
   <p:cSld>
     <p:spTree>
       <p:nvGrpSpPr>
@@ -5093,7 +4887,14 @@
         <p:cNvGrpSpPr/>
         <p:nvPr/>
       </p:nvGrpSpPr>
-      <p:grpSpPr/>
+      <p:grpSpPr>
+        <a:xfrm>
+          <a:off x="0" y="0"/>
+          <a:ext cx="0" cy="0"/>
+          <a:chOff x="0" y="0"/>
+          <a:chExt cx="0" cy="0"/>
+        </a:xfrm>
+      </p:grpSpPr>
       <p:sp>
         <p:nvSpPr>
           <p:cNvPr id="2" name="Rectangle 1"/>
@@ -5134,6 +4935,7 @@
           <a:lstStyle/>
           <a:p>
             <a:pPr algn="ctr"/>
+            <a:endParaRPr/>
           </a:p>
         </p:txBody>
       </p:sp>
@@ -5279,6 +5081,7 @@
           <a:lstStyle/>
           <a:p>
             <a:pPr algn="ctr"/>
+            <a:endParaRPr/>
           </a:p>
         </p:txBody>
       </p:sp>
@@ -5393,6 +5196,7 @@
           <a:lstStyle/>
           <a:p>
             <a:pPr algn="ctr"/>
+            <a:endParaRPr/>
           </a:p>
         </p:txBody>
       </p:sp>
@@ -5508,6 +5312,7 @@
           <a:lstStyle/>
           <a:p>
             <a:pPr algn="ctr"/>
+            <a:endParaRPr/>
           </a:p>
         </p:txBody>
       </p:sp>
@@ -5623,6 +5428,7 @@
           <a:lstStyle/>
           <a:p>
             <a:pPr algn="ctr"/>
+            <a:endParaRPr/>
           </a:p>
         </p:txBody>
       </p:sp>
@@ -5738,6 +5544,7 @@
           <a:lstStyle/>
           <a:p>
             <a:pPr algn="ctr"/>
+            <a:endParaRPr/>
           </a:p>
         </p:txBody>
       </p:sp>
@@ -5853,6 +5660,7 @@
           <a:lstStyle/>
           <a:p>
             <a:pPr algn="ctr"/>
+            <a:endParaRPr/>
           </a:p>
         </p:txBody>
       </p:sp>
@@ -5935,7 +5743,7 @@
 </file>
 
 <file path=ppt/slides/slide12.xml><?xml version="1.0" encoding="utf-8"?>
-<p:sld xmlns:a="http://schemas.openxmlformats.org/drawingml/2006/main" xmlns:p="http://schemas.openxmlformats.org/presentationml/2006/main" xmlns:r="http://schemas.openxmlformats.org/officeDocument/2006/relationships">
+<p:sld xmlns:a="http://schemas.openxmlformats.org/drawingml/2006/main" xmlns:r="http://schemas.openxmlformats.org/officeDocument/2006/relationships" xmlns:p="http://schemas.openxmlformats.org/presentationml/2006/main">
   <p:cSld>
     <p:spTree>
       <p:nvGrpSpPr>
@@ -5943,7 +5751,14 @@
         <p:cNvGrpSpPr/>
         <p:nvPr/>
       </p:nvGrpSpPr>
-      <p:grpSpPr/>
+      <p:grpSpPr>
+        <a:xfrm>
+          <a:off x="0" y="0"/>
+          <a:ext cx="0" cy="0"/>
+          <a:chOff x="0" y="0"/>
+          <a:chExt cx="0" cy="0"/>
+        </a:xfrm>
+      </p:grpSpPr>
       <p:sp>
         <p:nvSpPr>
           <p:cNvPr id="2" name="Rectangle 1"/>
@@ -5984,6 +5799,7 @@
           <a:lstStyle/>
           <a:p>
             <a:pPr algn="ctr"/>
+            <a:endParaRPr/>
           </a:p>
         </p:txBody>
       </p:sp>
@@ -6129,6 +5945,7 @@
           <a:lstStyle/>
           <a:p>
             <a:pPr algn="ctr"/>
+            <a:endParaRPr/>
           </a:p>
         </p:txBody>
       </p:sp>
@@ -6243,6 +6060,7 @@
           <a:lstStyle/>
           <a:p>
             <a:pPr algn="ctr"/>
+            <a:endParaRPr/>
           </a:p>
         </p:txBody>
       </p:sp>
@@ -6393,6 +6211,7 @@
           <a:lstStyle/>
           <a:p>
             <a:pPr algn="ctr"/>
+            <a:endParaRPr/>
           </a:p>
         </p:txBody>
       </p:sp>
@@ -6543,6 +6362,7 @@
           <a:lstStyle/>
           <a:p>
             <a:pPr algn="ctr"/>
+            <a:endParaRPr/>
           </a:p>
         </p:txBody>
       </p:sp>
@@ -6693,6 +6513,7 @@
           <a:lstStyle/>
           <a:p>
             <a:pPr algn="ctr"/>
+            <a:endParaRPr/>
           </a:p>
         </p:txBody>
       </p:sp>
@@ -6843,6 +6664,7 @@
           <a:lstStyle/>
           <a:p>
             <a:pPr algn="ctr"/>
+            <a:endParaRPr/>
           </a:p>
         </p:txBody>
       </p:sp>
@@ -6993,6 +6815,7 @@
           <a:lstStyle/>
           <a:p>
             <a:pPr algn="ctr"/>
+            <a:endParaRPr/>
           </a:p>
         </p:txBody>
       </p:sp>
@@ -7143,6 +6966,7 @@
           <a:lstStyle/>
           <a:p>
             <a:pPr algn="ctr"/>
+            <a:endParaRPr/>
           </a:p>
         </p:txBody>
       </p:sp>
@@ -7293,6 +7117,7 @@
           <a:lstStyle/>
           <a:p>
             <a:pPr algn="ctr"/>
+            <a:endParaRPr/>
           </a:p>
         </p:txBody>
       </p:sp>
@@ -7408,6 +7233,7 @@
           <a:lstStyle/>
           <a:p>
             <a:pPr algn="ctr"/>
+            <a:endParaRPr/>
           </a:p>
         </p:txBody>
       </p:sp>
@@ -7451,6 +7277,7 @@
           <a:lstStyle/>
           <a:p>
             <a:pPr algn="ctr"/>
+            <a:endParaRPr/>
           </a:p>
         </p:txBody>
       </p:sp>
@@ -7566,6 +7393,7 @@
           <a:lstStyle/>
           <a:p>
             <a:pPr algn="ctr"/>
+            <a:endParaRPr/>
           </a:p>
         </p:txBody>
       </p:sp>
@@ -7609,6 +7437,7 @@
           <a:lstStyle/>
           <a:p>
             <a:pPr algn="ctr"/>
+            <a:endParaRPr/>
           </a:p>
         </p:txBody>
       </p:sp>
@@ -7724,6 +7553,7 @@
           <a:lstStyle/>
           <a:p>
             <a:pPr algn="ctr"/>
+            <a:endParaRPr/>
           </a:p>
         </p:txBody>
       </p:sp>
@@ -7767,6 +7597,7 @@
           <a:lstStyle/>
           <a:p>
             <a:pPr algn="ctr"/>
+            <a:endParaRPr/>
           </a:p>
         </p:txBody>
       </p:sp>
@@ -7849,7 +7680,7 @@
 </file>
 
 <file path=ppt/slides/slide13.xml><?xml version="1.0" encoding="utf-8"?>
-<p:sld xmlns:a="http://schemas.openxmlformats.org/drawingml/2006/main" xmlns:p="http://schemas.openxmlformats.org/presentationml/2006/main" xmlns:r="http://schemas.openxmlformats.org/officeDocument/2006/relationships">
+<p:sld xmlns:a="http://schemas.openxmlformats.org/drawingml/2006/main" xmlns:r="http://schemas.openxmlformats.org/officeDocument/2006/relationships" xmlns:p="http://schemas.openxmlformats.org/presentationml/2006/main">
   <p:cSld>
     <p:spTree>
       <p:nvGrpSpPr>
@@ -7857,7 +7688,14 @@
         <p:cNvGrpSpPr/>
         <p:nvPr/>
       </p:nvGrpSpPr>
-      <p:grpSpPr/>
+      <p:grpSpPr>
+        <a:xfrm>
+          <a:off x="0" y="0"/>
+          <a:ext cx="0" cy="0"/>
+          <a:chOff x="0" y="0"/>
+          <a:chExt cx="0" cy="0"/>
+        </a:xfrm>
+      </p:grpSpPr>
       <p:sp>
         <p:nvSpPr>
           <p:cNvPr id="2" name="Rectangle 1"/>
@@ -7898,6 +7736,7 @@
           <a:lstStyle/>
           <a:p>
             <a:pPr algn="ctr"/>
+            <a:endParaRPr/>
           </a:p>
         </p:txBody>
       </p:sp>
@@ -8043,6 +7882,7 @@
           <a:lstStyle/>
           <a:p>
             <a:pPr algn="ctr"/>
+            <a:endParaRPr/>
           </a:p>
         </p:txBody>
       </p:sp>
@@ -8157,6 +7997,7 @@
           <a:lstStyle/>
           <a:p>
             <a:pPr algn="ctr"/>
+            <a:endParaRPr/>
           </a:p>
         </p:txBody>
       </p:sp>
@@ -8272,6 +8113,7 @@
           <a:lstStyle/>
           <a:p>
             <a:pPr algn="ctr"/>
+            <a:endParaRPr/>
           </a:p>
         </p:txBody>
       </p:sp>
@@ -8387,6 +8229,7 @@
           <a:lstStyle/>
           <a:p>
             <a:pPr algn="ctr"/>
+            <a:endParaRPr/>
           </a:p>
         </p:txBody>
       </p:sp>
@@ -8502,6 +8345,7 @@
           <a:lstStyle/>
           <a:p>
             <a:pPr algn="ctr"/>
+            <a:endParaRPr/>
           </a:p>
         </p:txBody>
       </p:sp>
@@ -8617,6 +8461,7 @@
           <a:lstStyle/>
           <a:p>
             <a:pPr algn="ctr"/>
+            <a:endParaRPr/>
           </a:p>
         </p:txBody>
       </p:sp>
@@ -8732,6 +8577,7 @@
           <a:lstStyle/>
           <a:p>
             <a:pPr algn="ctr"/>
+            <a:endParaRPr/>
           </a:p>
         </p:txBody>
       </p:sp>
@@ -8775,6 +8621,7 @@
           <a:lstStyle/>
           <a:p>
             <a:pPr algn="ctr"/>
+            <a:endParaRPr/>
           </a:p>
         </p:txBody>
       </p:sp>
@@ -8890,6 +8737,7 @@
           <a:lstStyle/>
           <a:p>
             <a:pPr algn="ctr"/>
+            <a:endParaRPr/>
           </a:p>
         </p:txBody>
       </p:sp>
@@ -8933,6 +8781,7 @@
           <a:lstStyle/>
           <a:p>
             <a:pPr algn="ctr"/>
+            <a:endParaRPr/>
           </a:p>
         </p:txBody>
       </p:sp>
@@ -9048,6 +8897,7 @@
           <a:lstStyle/>
           <a:p>
             <a:pPr algn="ctr"/>
+            <a:endParaRPr/>
           </a:p>
         </p:txBody>
       </p:sp>
@@ -9091,6 +8941,7 @@
           <a:lstStyle/>
           <a:p>
             <a:pPr algn="ctr"/>
+            <a:endParaRPr/>
           </a:p>
         </p:txBody>
       </p:sp>
@@ -9206,6 +9057,7 @@
           <a:lstStyle/>
           <a:p>
             <a:pPr algn="ctr"/>
+            <a:endParaRPr/>
           </a:p>
         </p:txBody>
       </p:sp>
@@ -9249,6 +9101,7 @@
           <a:lstStyle/>
           <a:p>
             <a:pPr algn="ctr"/>
+            <a:endParaRPr/>
           </a:p>
         </p:txBody>
       </p:sp>
@@ -9364,6 +9217,7 @@
           <a:lstStyle/>
           <a:p>
             <a:pPr algn="ctr"/>
+            <a:endParaRPr/>
           </a:p>
         </p:txBody>
       </p:sp>
@@ -9407,6 +9261,7 @@
           <a:lstStyle/>
           <a:p>
             <a:pPr algn="ctr"/>
+            <a:endParaRPr/>
           </a:p>
         </p:txBody>
       </p:sp>
@@ -9489,7 +9344,7 @@
 </file>
 
 <file path=ppt/slides/slide14.xml><?xml version="1.0" encoding="utf-8"?>
-<p:sld xmlns:a="http://schemas.openxmlformats.org/drawingml/2006/main" xmlns:p="http://schemas.openxmlformats.org/presentationml/2006/main" xmlns:r="http://schemas.openxmlformats.org/officeDocument/2006/relationships">
+<p:sld xmlns:a="http://schemas.openxmlformats.org/drawingml/2006/main" xmlns:r="http://schemas.openxmlformats.org/officeDocument/2006/relationships" xmlns:p="http://schemas.openxmlformats.org/presentationml/2006/main">
   <p:cSld>
     <p:spTree>
       <p:nvGrpSpPr>
@@ -9497,7 +9352,14 @@
         <p:cNvGrpSpPr/>
         <p:nvPr/>
       </p:nvGrpSpPr>
-      <p:grpSpPr/>
+      <p:grpSpPr>
+        <a:xfrm>
+          <a:off x="0" y="0"/>
+          <a:ext cx="0" cy="0"/>
+          <a:chOff x="0" y="0"/>
+          <a:chExt cx="0" cy="0"/>
+        </a:xfrm>
+      </p:grpSpPr>
       <p:sp>
         <p:nvSpPr>
           <p:cNvPr id="2" name="Rectangle 1"/>
@@ -9538,6 +9400,7 @@
           <a:lstStyle/>
           <a:p>
             <a:pPr algn="ctr"/>
+            <a:endParaRPr/>
           </a:p>
         </p:txBody>
       </p:sp>
@@ -9683,6 +9546,7 @@
           <a:lstStyle/>
           <a:p>
             <a:pPr algn="ctr"/>
+            <a:endParaRPr/>
           </a:p>
         </p:txBody>
       </p:sp>
@@ -9797,6 +9661,7 @@
           <a:lstStyle/>
           <a:p>
             <a:pPr algn="ctr"/>
+            <a:endParaRPr/>
           </a:p>
         </p:txBody>
       </p:sp>
@@ -9840,6 +9705,7 @@
           <a:lstStyle/>
           <a:p>
             <a:pPr algn="ctr"/>
+            <a:endParaRPr/>
           </a:p>
         </p:txBody>
       </p:sp>
@@ -9995,6 +9861,7 @@
           <a:lstStyle/>
           <a:p>
             <a:pPr algn="ctr"/>
+            <a:endParaRPr/>
           </a:p>
         </p:txBody>
       </p:sp>
@@ -10038,6 +9905,7 @@
           <a:lstStyle/>
           <a:p>
             <a:pPr algn="ctr"/>
+            <a:endParaRPr/>
           </a:p>
         </p:txBody>
       </p:sp>
@@ -10191,6 +10059,7 @@
           <a:lstStyle/>
           <a:p>
             <a:pPr algn="ctr"/>
+            <a:endParaRPr/>
           </a:p>
         </p:txBody>
       </p:sp>
@@ -10234,6 +10103,7 @@
           <a:lstStyle/>
           <a:p>
             <a:pPr algn="ctr"/>
+            <a:endParaRPr/>
           </a:p>
         </p:txBody>
       </p:sp>
@@ -10386,6 +10256,7 @@
           <a:lstStyle/>
           <a:p>
             <a:pPr algn="ctr"/>
+            <a:endParaRPr/>
           </a:p>
         </p:txBody>
       </p:sp>
@@ -10429,6 +10300,7 @@
           <a:lstStyle/>
           <a:p>
             <a:pPr algn="ctr"/>
+            <a:endParaRPr/>
           </a:p>
         </p:txBody>
       </p:sp>
@@ -10581,6 +10453,7 @@
           <a:lstStyle/>
           <a:p>
             <a:pPr algn="ctr"/>
+            <a:endParaRPr/>
           </a:p>
         </p:txBody>
       </p:sp>
@@ -10624,6 +10497,7 @@
           <a:lstStyle/>
           <a:p>
             <a:pPr algn="ctr"/>
+            <a:endParaRPr/>
           </a:p>
         </p:txBody>
       </p:sp>
@@ -10743,7 +10617,7 @@
 </file>
 
 <file path=ppt/slides/slide15.xml><?xml version="1.0" encoding="utf-8"?>
-<p:sld xmlns:a="http://schemas.openxmlformats.org/drawingml/2006/main" xmlns:p="http://schemas.openxmlformats.org/presentationml/2006/main" xmlns:r="http://schemas.openxmlformats.org/officeDocument/2006/relationships">
+<p:sld xmlns:a="http://schemas.openxmlformats.org/drawingml/2006/main" xmlns:r="http://schemas.openxmlformats.org/officeDocument/2006/relationships" xmlns:p="http://schemas.openxmlformats.org/presentationml/2006/main">
   <p:cSld>
     <p:spTree>
       <p:nvGrpSpPr>
@@ -10751,7 +10625,14 @@
         <p:cNvGrpSpPr/>
         <p:nvPr/>
       </p:nvGrpSpPr>
-      <p:grpSpPr/>
+      <p:grpSpPr>
+        <a:xfrm>
+          <a:off x="0" y="0"/>
+          <a:ext cx="0" cy="0"/>
+          <a:chOff x="0" y="0"/>
+          <a:chExt cx="0" cy="0"/>
+        </a:xfrm>
+      </p:grpSpPr>
       <p:sp>
         <p:nvSpPr>
           <p:cNvPr id="2" name="Rectangle 1"/>
@@ -10792,6 +10673,7 @@
           <a:lstStyle/>
           <a:p>
             <a:pPr algn="ctr"/>
+            <a:endParaRPr/>
           </a:p>
         </p:txBody>
       </p:sp>
@@ -10937,6 +10819,7 @@
           <a:lstStyle/>
           <a:p>
             <a:pPr algn="ctr"/>
+            <a:endParaRPr/>
           </a:p>
         </p:txBody>
       </p:sp>
@@ -11051,6 +10934,7 @@
           <a:lstStyle/>
           <a:p>
             <a:pPr algn="ctr"/>
+            <a:endParaRPr/>
           </a:p>
         </p:txBody>
       </p:sp>
@@ -11094,6 +10978,7 @@
           <a:lstStyle/>
           <a:p>
             <a:pPr algn="ctr"/>
+            <a:endParaRPr/>
           </a:p>
         </p:txBody>
       </p:sp>
@@ -11209,6 +11094,7 @@
           <a:lstStyle/>
           <a:p>
             <a:pPr algn="ctr"/>
+            <a:endParaRPr/>
           </a:p>
         </p:txBody>
       </p:sp>
@@ -11252,6 +11138,7 @@
           <a:lstStyle/>
           <a:p>
             <a:pPr algn="ctr"/>
+            <a:endParaRPr/>
           </a:p>
         </p:txBody>
       </p:sp>
@@ -11367,6 +11254,7 @@
           <a:lstStyle/>
           <a:p>
             <a:pPr algn="ctr"/>
+            <a:endParaRPr/>
           </a:p>
         </p:txBody>
       </p:sp>
@@ -11410,6 +11298,7 @@
           <a:lstStyle/>
           <a:p>
             <a:pPr algn="ctr"/>
+            <a:endParaRPr/>
           </a:p>
         </p:txBody>
       </p:sp>
@@ -11525,6 +11414,7 @@
           <a:lstStyle/>
           <a:p>
             <a:pPr algn="ctr"/>
+            <a:endParaRPr/>
           </a:p>
         </p:txBody>
       </p:sp>
@@ -11568,6 +11458,7 @@
           <a:lstStyle/>
           <a:p>
             <a:pPr algn="ctr"/>
+            <a:endParaRPr/>
           </a:p>
         </p:txBody>
       </p:sp>
@@ -11683,6 +11574,7 @@
           <a:lstStyle/>
           <a:p>
             <a:pPr algn="ctr"/>
+            <a:endParaRPr/>
           </a:p>
         </p:txBody>
       </p:sp>
@@ -11726,6 +11618,7 @@
           <a:lstStyle/>
           <a:p>
             <a:pPr algn="ctr"/>
+            <a:endParaRPr/>
           </a:p>
         </p:txBody>
       </p:sp>
@@ -11841,6 +11734,7 @@
           <a:lstStyle/>
           <a:p>
             <a:pPr algn="ctr"/>
+            <a:endParaRPr/>
           </a:p>
         </p:txBody>
       </p:sp>
@@ -11884,6 +11778,7 @@
           <a:lstStyle/>
           <a:p>
             <a:pPr algn="ctr"/>
+            <a:endParaRPr/>
           </a:p>
         </p:txBody>
       </p:sp>
@@ -11966,7 +11861,7 @@
 </file>
 
 <file path=ppt/slides/slide16.xml><?xml version="1.0" encoding="utf-8"?>
-<p:sld xmlns:a="http://schemas.openxmlformats.org/drawingml/2006/main" xmlns:p="http://schemas.openxmlformats.org/presentationml/2006/main" xmlns:r="http://schemas.openxmlformats.org/officeDocument/2006/relationships">
+<p:sld xmlns:a="http://schemas.openxmlformats.org/drawingml/2006/main" xmlns:r="http://schemas.openxmlformats.org/officeDocument/2006/relationships" xmlns:p="http://schemas.openxmlformats.org/presentationml/2006/main">
   <p:cSld>
     <p:spTree>
       <p:nvGrpSpPr>
@@ -11974,7 +11869,14 @@
         <p:cNvGrpSpPr/>
         <p:nvPr/>
       </p:nvGrpSpPr>
-      <p:grpSpPr/>
+      <p:grpSpPr>
+        <a:xfrm>
+          <a:off x="0" y="0"/>
+          <a:ext cx="0" cy="0"/>
+          <a:chOff x="0" y="0"/>
+          <a:chExt cx="0" cy="0"/>
+        </a:xfrm>
+      </p:grpSpPr>
       <p:sp>
         <p:nvSpPr>
           <p:cNvPr id="2" name="Rectangle 1"/>
@@ -12015,6 +11917,7 @@
           <a:lstStyle/>
           <a:p>
             <a:pPr algn="ctr"/>
+            <a:endParaRPr/>
           </a:p>
         </p:txBody>
       </p:sp>
@@ -12160,6 +12063,7 @@
           <a:lstStyle/>
           <a:p>
             <a:pPr algn="ctr"/>
+            <a:endParaRPr/>
           </a:p>
         </p:txBody>
       </p:sp>
@@ -12274,6 +12178,7 @@
           <a:lstStyle/>
           <a:p>
             <a:pPr algn="ctr"/>
+            <a:endParaRPr/>
           </a:p>
         </p:txBody>
       </p:sp>
@@ -12317,6 +12222,7 @@
           <a:lstStyle/>
           <a:p>
             <a:pPr algn="ctr"/>
+            <a:endParaRPr/>
           </a:p>
         </p:txBody>
       </p:sp>
@@ -12432,6 +12338,7 @@
           <a:lstStyle/>
           <a:p>
             <a:pPr algn="ctr"/>
+            <a:endParaRPr/>
           </a:p>
         </p:txBody>
       </p:sp>
@@ -12475,6 +12382,7 @@
           <a:lstStyle/>
           <a:p>
             <a:pPr algn="ctr"/>
+            <a:endParaRPr/>
           </a:p>
         </p:txBody>
       </p:sp>
@@ -12590,6 +12498,7 @@
           <a:lstStyle/>
           <a:p>
             <a:pPr algn="ctr"/>
+            <a:endParaRPr/>
           </a:p>
         </p:txBody>
       </p:sp>
@@ -12633,6 +12542,7 @@
           <a:lstStyle/>
           <a:p>
             <a:pPr algn="ctr"/>
+            <a:endParaRPr/>
           </a:p>
         </p:txBody>
       </p:sp>
@@ -12748,6 +12658,7 @@
           <a:lstStyle/>
           <a:p>
             <a:pPr algn="ctr"/>
+            <a:endParaRPr/>
           </a:p>
         </p:txBody>
       </p:sp>
@@ -12791,6 +12702,7 @@
           <a:lstStyle/>
           <a:p>
             <a:pPr algn="ctr"/>
+            <a:endParaRPr/>
           </a:p>
         </p:txBody>
       </p:sp>
@@ -12906,6 +12818,7 @@
           <a:lstStyle/>
           <a:p>
             <a:pPr algn="ctr"/>
+            <a:endParaRPr/>
           </a:p>
         </p:txBody>
       </p:sp>
@@ -12949,6 +12862,7 @@
           <a:lstStyle/>
           <a:p>
             <a:pPr algn="ctr"/>
+            <a:endParaRPr/>
           </a:p>
         </p:txBody>
       </p:sp>
@@ -13064,6 +12978,7 @@
           <a:lstStyle/>
           <a:p>
             <a:pPr algn="ctr"/>
+            <a:endParaRPr/>
           </a:p>
         </p:txBody>
       </p:sp>
@@ -13107,6 +13022,7 @@
           <a:lstStyle/>
           <a:p>
             <a:pPr algn="ctr"/>
+            <a:endParaRPr/>
           </a:p>
         </p:txBody>
       </p:sp>
@@ -13222,6 +13138,7 @@
           <a:lstStyle/>
           <a:p>
             <a:pPr algn="ctr"/>
+            <a:endParaRPr/>
           </a:p>
         </p:txBody>
       </p:sp>
@@ -13265,6 +13182,7 @@
           <a:lstStyle/>
           <a:p>
             <a:pPr algn="ctr"/>
+            <a:endParaRPr/>
           </a:p>
         </p:txBody>
       </p:sp>
@@ -13380,6 +13298,7 @@
           <a:lstStyle/>
           <a:p>
             <a:pPr algn="ctr"/>
+            <a:endParaRPr/>
           </a:p>
         </p:txBody>
       </p:sp>
@@ -13423,6 +13342,7 @@
           <a:lstStyle/>
           <a:p>
             <a:pPr algn="ctr"/>
+            <a:endParaRPr/>
           </a:p>
         </p:txBody>
       </p:sp>
@@ -13505,7 +13425,7 @@
 </file>
 
 <file path=ppt/slides/slide17.xml><?xml version="1.0" encoding="utf-8"?>
-<p:sld xmlns:a="http://schemas.openxmlformats.org/drawingml/2006/main" xmlns:p="http://schemas.openxmlformats.org/presentationml/2006/main" xmlns:r="http://schemas.openxmlformats.org/officeDocument/2006/relationships">
+<p:sld xmlns:a="http://schemas.openxmlformats.org/drawingml/2006/main" xmlns:r="http://schemas.openxmlformats.org/officeDocument/2006/relationships" xmlns:p="http://schemas.openxmlformats.org/presentationml/2006/main">
   <p:cSld>
     <p:spTree>
       <p:nvGrpSpPr>
@@ -13513,7 +13433,14 @@
         <p:cNvGrpSpPr/>
         <p:nvPr/>
       </p:nvGrpSpPr>
-      <p:grpSpPr/>
+      <p:grpSpPr>
+        <a:xfrm>
+          <a:off x="0" y="0"/>
+          <a:ext cx="0" cy="0"/>
+          <a:chOff x="0" y="0"/>
+          <a:chExt cx="0" cy="0"/>
+        </a:xfrm>
+      </p:grpSpPr>
       <p:sp>
         <p:nvSpPr>
           <p:cNvPr id="2" name="Rectangle 1"/>
@@ -13554,6 +13481,7 @@
           <a:lstStyle/>
           <a:p>
             <a:pPr algn="ctr"/>
+            <a:endParaRPr/>
           </a:p>
         </p:txBody>
       </p:sp>
@@ -13699,6 +13627,7 @@
           <a:lstStyle/>
           <a:p>
             <a:pPr algn="ctr"/>
+            <a:endParaRPr/>
           </a:p>
         </p:txBody>
       </p:sp>
@@ -13813,6 +13742,7 @@
           <a:lstStyle/>
           <a:p>
             <a:pPr algn="ctr"/>
+            <a:endParaRPr/>
           </a:p>
         </p:txBody>
       </p:sp>
@@ -13928,6 +13858,7 @@
           <a:lstStyle/>
           <a:p>
             <a:pPr algn="ctr"/>
+            <a:endParaRPr/>
           </a:p>
         </p:txBody>
       </p:sp>
@@ -14043,6 +13974,7 @@
           <a:lstStyle/>
           <a:p>
             <a:pPr algn="ctr"/>
+            <a:endParaRPr/>
           </a:p>
         </p:txBody>
       </p:sp>
@@ -14158,6 +14090,7 @@
           <a:lstStyle/>
           <a:p>
             <a:pPr algn="ctr"/>
+            <a:endParaRPr/>
           </a:p>
         </p:txBody>
       </p:sp>
@@ -14273,6 +14206,7 @@
           <a:lstStyle/>
           <a:p>
             <a:pPr algn="ctr"/>
+            <a:endParaRPr/>
           </a:p>
         </p:txBody>
       </p:sp>
@@ -14563,6 +14497,7 @@
           <a:lstStyle/>
           <a:p>
             <a:pPr algn="ctr"/>
+            <a:endParaRPr/>
           </a:p>
         </p:txBody>
       </p:sp>
@@ -14606,6 +14541,7 @@
           <a:lstStyle/>
           <a:p>
             <a:pPr algn="ctr"/>
+            <a:endParaRPr/>
           </a:p>
         </p:txBody>
       </p:sp>
@@ -14721,6 +14657,7 @@
           <a:lstStyle/>
           <a:p>
             <a:pPr algn="ctr"/>
+            <a:endParaRPr/>
           </a:p>
         </p:txBody>
       </p:sp>
@@ -14764,6 +14701,7 @@
           <a:lstStyle/>
           <a:p>
             <a:pPr algn="ctr"/>
+            <a:endParaRPr/>
           </a:p>
         </p:txBody>
       </p:sp>
@@ -14879,6 +14817,7 @@
           <a:lstStyle/>
           <a:p>
             <a:pPr algn="ctr"/>
+            <a:endParaRPr/>
           </a:p>
         </p:txBody>
       </p:sp>
@@ -14922,6 +14861,7 @@
           <a:lstStyle/>
           <a:p>
             <a:pPr algn="ctr"/>
+            <a:endParaRPr/>
           </a:p>
         </p:txBody>
       </p:sp>
@@ -15037,6 +14977,7 @@
           <a:lstStyle/>
           <a:p>
             <a:pPr algn="ctr"/>
+            <a:endParaRPr/>
           </a:p>
         </p:txBody>
       </p:sp>
@@ -15080,6 +15021,7 @@
           <a:lstStyle/>
           <a:p>
             <a:pPr algn="ctr"/>
+            <a:endParaRPr/>
           </a:p>
         </p:txBody>
       </p:sp>
@@ -15162,7 +15104,7 @@
 </file>
 
 <file path=ppt/slides/slide18.xml><?xml version="1.0" encoding="utf-8"?>
-<p:sld xmlns:a="http://schemas.openxmlformats.org/drawingml/2006/main" xmlns:p="http://schemas.openxmlformats.org/presentationml/2006/main" xmlns:r="http://schemas.openxmlformats.org/officeDocument/2006/relationships">
+<p:sld xmlns:a="http://schemas.openxmlformats.org/drawingml/2006/main" xmlns:r="http://schemas.openxmlformats.org/officeDocument/2006/relationships" xmlns:p="http://schemas.openxmlformats.org/presentationml/2006/main">
   <p:cSld>
     <p:spTree>
       <p:nvGrpSpPr>
@@ -15170,7 +15112,14 @@
         <p:cNvGrpSpPr/>
         <p:nvPr/>
       </p:nvGrpSpPr>
-      <p:grpSpPr/>
+      <p:grpSpPr>
+        <a:xfrm>
+          <a:off x="0" y="0"/>
+          <a:ext cx="0" cy="0"/>
+          <a:chOff x="0" y="0"/>
+          <a:chExt cx="0" cy="0"/>
+        </a:xfrm>
+      </p:grpSpPr>
       <p:sp>
         <p:nvSpPr>
           <p:cNvPr id="2" name="Rectangle 1"/>
@@ -15211,6 +15160,7 @@
           <a:lstStyle/>
           <a:p>
             <a:pPr algn="ctr"/>
+            <a:endParaRPr/>
           </a:p>
         </p:txBody>
       </p:sp>
@@ -15356,6 +15306,7 @@
           <a:lstStyle/>
           <a:p>
             <a:pPr algn="ctr"/>
+            <a:endParaRPr/>
           </a:p>
         </p:txBody>
       </p:sp>
@@ -15470,6 +15421,7 @@
           <a:lstStyle/>
           <a:p>
             <a:pPr algn="ctr"/>
+            <a:endParaRPr/>
           </a:p>
         </p:txBody>
       </p:sp>
@@ -15513,6 +15465,7 @@
           <a:lstStyle/>
           <a:p>
             <a:pPr algn="ctr"/>
+            <a:endParaRPr/>
           </a:p>
         </p:txBody>
       </p:sp>
@@ -15628,6 +15581,7 @@
           <a:lstStyle/>
           <a:p>
             <a:pPr algn="ctr"/>
+            <a:endParaRPr/>
           </a:p>
         </p:txBody>
       </p:sp>
@@ -15671,6 +15625,7 @@
           <a:lstStyle/>
           <a:p>
             <a:pPr algn="ctr"/>
+            <a:endParaRPr/>
           </a:p>
         </p:txBody>
       </p:sp>
@@ -15786,6 +15741,7 @@
           <a:lstStyle/>
           <a:p>
             <a:pPr algn="ctr"/>
+            <a:endParaRPr/>
           </a:p>
         </p:txBody>
       </p:sp>
@@ -15829,6 +15785,7 @@
           <a:lstStyle/>
           <a:p>
             <a:pPr algn="ctr"/>
+            <a:endParaRPr/>
           </a:p>
         </p:txBody>
       </p:sp>
@@ -15944,6 +15901,7 @@
           <a:lstStyle/>
           <a:p>
             <a:pPr algn="ctr"/>
+            <a:endParaRPr/>
           </a:p>
         </p:txBody>
       </p:sp>
@@ -15987,6 +15945,7 @@
           <a:lstStyle/>
           <a:p>
             <a:pPr algn="ctr"/>
+            <a:endParaRPr/>
           </a:p>
         </p:txBody>
       </p:sp>
@@ -16102,6 +16061,7 @@
           <a:lstStyle/>
           <a:p>
             <a:pPr algn="ctr"/>
+            <a:endParaRPr/>
           </a:p>
         </p:txBody>
       </p:sp>
@@ -16145,6 +16105,7 @@
           <a:lstStyle/>
           <a:p>
             <a:pPr algn="ctr"/>
+            <a:endParaRPr/>
           </a:p>
         </p:txBody>
       </p:sp>
@@ -16260,6 +16221,7 @@
           <a:lstStyle/>
           <a:p>
             <a:pPr algn="ctr"/>
+            <a:endParaRPr/>
           </a:p>
         </p:txBody>
       </p:sp>
@@ -16303,6 +16265,7 @@
           <a:lstStyle/>
           <a:p>
             <a:pPr algn="ctr"/>
+            <a:endParaRPr/>
           </a:p>
         </p:txBody>
       </p:sp>
@@ -16420,7 +16383,7 @@
 </file>
 
 <file path=ppt/slides/slide19.xml><?xml version="1.0" encoding="utf-8"?>
-<p:sld xmlns:a="http://schemas.openxmlformats.org/drawingml/2006/main" xmlns:p="http://schemas.openxmlformats.org/presentationml/2006/main" xmlns:r="http://schemas.openxmlformats.org/officeDocument/2006/relationships">
+<p:sld xmlns:a="http://schemas.openxmlformats.org/drawingml/2006/main" xmlns:r="http://schemas.openxmlformats.org/officeDocument/2006/relationships" xmlns:p="http://schemas.openxmlformats.org/presentationml/2006/main">
   <p:cSld>
     <p:spTree>
       <p:nvGrpSpPr>
@@ -16428,7 +16391,14 @@
         <p:cNvGrpSpPr/>
         <p:nvPr/>
       </p:nvGrpSpPr>
-      <p:grpSpPr/>
+      <p:grpSpPr>
+        <a:xfrm>
+          <a:off x="0" y="0"/>
+          <a:ext cx="0" cy="0"/>
+          <a:chOff x="0" y="0"/>
+          <a:chExt cx="0" cy="0"/>
+        </a:xfrm>
+      </p:grpSpPr>
       <p:sp>
         <p:nvSpPr>
           <p:cNvPr id="2" name="Rectangle 1"/>
@@ -16469,6 +16439,7 @@
           <a:lstStyle/>
           <a:p>
             <a:pPr algn="ctr"/>
+            <a:endParaRPr/>
           </a:p>
         </p:txBody>
       </p:sp>
@@ -16614,6 +16585,7 @@
           <a:lstStyle/>
           <a:p>
             <a:pPr algn="ctr"/>
+            <a:endParaRPr/>
           </a:p>
         </p:txBody>
       </p:sp>
@@ -16868,6 +16840,7 @@
           <a:lstStyle/>
           <a:p>
             <a:pPr algn="ctr"/>
+            <a:endParaRPr/>
           </a:p>
         </p:txBody>
       </p:sp>
@@ -16911,6 +16884,7 @@
           <a:lstStyle/>
           <a:p>
             <a:pPr algn="ctr"/>
+            <a:endParaRPr/>
           </a:p>
         </p:txBody>
       </p:sp>
@@ -17026,6 +17000,7 @@
           <a:lstStyle/>
           <a:p>
             <a:pPr algn="ctr"/>
+            <a:endParaRPr/>
           </a:p>
         </p:txBody>
       </p:sp>
@@ -17069,6 +17044,7 @@
           <a:lstStyle/>
           <a:p>
             <a:pPr algn="ctr"/>
+            <a:endParaRPr/>
           </a:p>
         </p:txBody>
       </p:sp>
@@ -17184,6 +17160,7 @@
           <a:lstStyle/>
           <a:p>
             <a:pPr algn="ctr"/>
+            <a:endParaRPr/>
           </a:p>
         </p:txBody>
       </p:sp>
@@ -17227,6 +17204,7 @@
           <a:lstStyle/>
           <a:p>
             <a:pPr algn="ctr"/>
+            <a:endParaRPr/>
           </a:p>
         </p:txBody>
       </p:sp>
@@ -17344,7 +17322,7 @@
 </file>
 
 <file path=ppt/slides/slide2.xml><?xml version="1.0" encoding="utf-8"?>
-<p:sld xmlns:a="http://schemas.openxmlformats.org/drawingml/2006/main" xmlns:p="http://schemas.openxmlformats.org/presentationml/2006/main" xmlns:r="http://schemas.openxmlformats.org/officeDocument/2006/relationships">
+<p:sld xmlns:a="http://schemas.openxmlformats.org/drawingml/2006/main" xmlns:r="http://schemas.openxmlformats.org/officeDocument/2006/relationships" xmlns:p="http://schemas.openxmlformats.org/presentationml/2006/main">
   <p:cSld>
     <p:spTree>
       <p:nvGrpSpPr>
@@ -17352,7 +17330,14 @@
         <p:cNvGrpSpPr/>
         <p:nvPr/>
       </p:nvGrpSpPr>
-      <p:grpSpPr/>
+      <p:grpSpPr>
+        <a:xfrm>
+          <a:off x="0" y="0"/>
+          <a:ext cx="0" cy="0"/>
+          <a:chOff x="0" y="0"/>
+          <a:chExt cx="0" cy="0"/>
+        </a:xfrm>
+      </p:grpSpPr>
       <p:sp>
         <p:nvSpPr>
           <p:cNvPr id="2" name="Rectangle 1"/>
@@ -17393,6 +17378,7 @@
           <a:lstStyle/>
           <a:p>
             <a:pPr algn="ctr"/>
+            <a:endParaRPr/>
           </a:p>
         </p:txBody>
       </p:sp>
@@ -17538,6 +17524,7 @@
           <a:lstStyle/>
           <a:p>
             <a:pPr algn="ctr"/>
+            <a:endParaRPr/>
           </a:p>
         </p:txBody>
       </p:sp>
@@ -17652,6 +17639,7 @@
           <a:lstStyle/>
           <a:p>
             <a:pPr algn="ctr"/>
+            <a:endParaRPr/>
           </a:p>
         </p:txBody>
       </p:sp>
@@ -17767,6 +17755,7 @@
           <a:lstStyle/>
           <a:p>
             <a:pPr algn="ctr"/>
+            <a:endParaRPr/>
           </a:p>
         </p:txBody>
       </p:sp>
@@ -17882,6 +17871,7 @@
           <a:lstStyle/>
           <a:p>
             <a:pPr algn="ctr"/>
+            <a:endParaRPr/>
           </a:p>
         </p:txBody>
       </p:sp>
@@ -17997,6 +17987,7 @@
           <a:lstStyle/>
           <a:p>
             <a:pPr algn="ctr"/>
+            <a:endParaRPr/>
           </a:p>
         </p:txBody>
       </p:sp>
@@ -18112,6 +18103,7 @@
           <a:lstStyle/>
           <a:p>
             <a:pPr algn="ctr"/>
+            <a:endParaRPr/>
           </a:p>
         </p:txBody>
       </p:sp>
@@ -18155,6 +18147,7 @@
           <a:lstStyle/>
           <a:p>
             <a:pPr algn="ctr"/>
+            <a:endParaRPr/>
           </a:p>
         </p:txBody>
       </p:sp>
@@ -18308,7 +18301,7 @@
 </file>
 
 <file path=ppt/slides/slide3.xml><?xml version="1.0" encoding="utf-8"?>
-<p:sld xmlns:a="http://schemas.openxmlformats.org/drawingml/2006/main" xmlns:p="http://schemas.openxmlformats.org/presentationml/2006/main" xmlns:r="http://schemas.openxmlformats.org/officeDocument/2006/relationships">
+<p:sld xmlns:a="http://schemas.openxmlformats.org/drawingml/2006/main" xmlns:r="http://schemas.openxmlformats.org/officeDocument/2006/relationships" xmlns:p="http://schemas.openxmlformats.org/presentationml/2006/main">
   <p:cSld>
     <p:spTree>
       <p:nvGrpSpPr>
@@ -18316,7 +18309,14 @@
         <p:cNvGrpSpPr/>
         <p:nvPr/>
       </p:nvGrpSpPr>
-      <p:grpSpPr/>
+      <p:grpSpPr>
+        <a:xfrm>
+          <a:off x="0" y="0"/>
+          <a:ext cx="0" cy="0"/>
+          <a:chOff x="0" y="0"/>
+          <a:chExt cx="0" cy="0"/>
+        </a:xfrm>
+      </p:grpSpPr>
       <p:sp>
         <p:nvSpPr>
           <p:cNvPr id="2" name="Rectangle 1"/>
@@ -18357,6 +18357,7 @@
           <a:lstStyle/>
           <a:p>
             <a:pPr algn="ctr"/>
+            <a:endParaRPr/>
           </a:p>
         </p:txBody>
       </p:sp>
@@ -18502,6 +18503,7 @@
           <a:lstStyle/>
           <a:p>
             <a:pPr algn="ctr"/>
+            <a:endParaRPr/>
           </a:p>
         </p:txBody>
       </p:sp>
@@ -18616,6 +18618,7 @@
           <a:lstStyle/>
           <a:p>
             <a:pPr algn="ctr"/>
+            <a:endParaRPr/>
           </a:p>
         </p:txBody>
       </p:sp>
@@ -18659,6 +18662,7 @@
           <a:lstStyle/>
           <a:p>
             <a:pPr algn="ctr"/>
+            <a:endParaRPr/>
           </a:p>
         </p:txBody>
       </p:sp>
@@ -18774,6 +18778,7 @@
           <a:lstStyle/>
           <a:p>
             <a:pPr algn="ctr"/>
+            <a:endParaRPr/>
           </a:p>
         </p:txBody>
       </p:sp>
@@ -18817,6 +18822,7 @@
           <a:lstStyle/>
           <a:p>
             <a:pPr algn="ctr"/>
+            <a:endParaRPr/>
           </a:p>
         </p:txBody>
       </p:sp>
@@ -18932,6 +18938,7 @@
           <a:lstStyle/>
           <a:p>
             <a:pPr algn="ctr"/>
+            <a:endParaRPr/>
           </a:p>
         </p:txBody>
       </p:sp>
@@ -18975,6 +18982,7 @@
           <a:lstStyle/>
           <a:p>
             <a:pPr algn="ctr"/>
+            <a:endParaRPr/>
           </a:p>
         </p:txBody>
       </p:sp>
@@ -19090,6 +19098,7 @@
           <a:lstStyle/>
           <a:p>
             <a:pPr algn="ctr"/>
+            <a:endParaRPr/>
           </a:p>
         </p:txBody>
       </p:sp>
@@ -19133,6 +19142,7 @@
           <a:lstStyle/>
           <a:p>
             <a:pPr algn="ctr"/>
+            <a:endParaRPr/>
           </a:p>
         </p:txBody>
       </p:sp>
@@ -19250,7 +19260,7 @@
 </file>
 
 <file path=ppt/slides/slide4.xml><?xml version="1.0" encoding="utf-8"?>
-<p:sld xmlns:a="http://schemas.openxmlformats.org/drawingml/2006/main" xmlns:p="http://schemas.openxmlformats.org/presentationml/2006/main" xmlns:r="http://schemas.openxmlformats.org/officeDocument/2006/relationships">
+<p:sld xmlns:a="http://schemas.openxmlformats.org/drawingml/2006/main" xmlns:r="http://schemas.openxmlformats.org/officeDocument/2006/relationships" xmlns:p="http://schemas.openxmlformats.org/presentationml/2006/main">
   <p:cSld>
     <p:spTree>
       <p:nvGrpSpPr>
@@ -19258,7 +19268,14 @@
         <p:cNvGrpSpPr/>
         <p:nvPr/>
       </p:nvGrpSpPr>
-      <p:grpSpPr/>
+      <p:grpSpPr>
+        <a:xfrm>
+          <a:off x="0" y="0"/>
+          <a:ext cx="0" cy="0"/>
+          <a:chOff x="0" y="0"/>
+          <a:chExt cx="0" cy="0"/>
+        </a:xfrm>
+      </p:grpSpPr>
       <p:sp>
         <p:nvSpPr>
           <p:cNvPr id="2" name="Rectangle 1"/>
@@ -19299,6 +19316,7 @@
           <a:lstStyle/>
           <a:p>
             <a:pPr algn="ctr"/>
+            <a:endParaRPr/>
           </a:p>
         </p:txBody>
       </p:sp>
@@ -19444,6 +19462,7 @@
           <a:lstStyle/>
           <a:p>
             <a:pPr algn="ctr"/>
+            <a:endParaRPr/>
           </a:p>
         </p:txBody>
       </p:sp>
@@ -19558,6 +19577,7 @@
           <a:lstStyle/>
           <a:p>
             <a:pPr algn="ctr"/>
+            <a:endParaRPr/>
           </a:p>
         </p:txBody>
       </p:sp>
@@ -19709,6 +19729,7 @@
           <a:lstStyle/>
           <a:p>
             <a:pPr algn="ctr"/>
+            <a:endParaRPr/>
           </a:p>
         </p:txBody>
       </p:sp>
@@ -19860,6 +19881,7 @@
           <a:lstStyle/>
           <a:p>
             <a:pPr algn="ctr"/>
+            <a:endParaRPr/>
           </a:p>
         </p:txBody>
       </p:sp>
@@ -20011,6 +20033,7 @@
           <a:lstStyle/>
           <a:p>
             <a:pPr algn="ctr"/>
+            <a:endParaRPr/>
           </a:p>
         </p:txBody>
       </p:sp>
@@ -20162,6 +20185,7 @@
           <a:lstStyle/>
           <a:p>
             <a:pPr algn="ctr"/>
+            <a:endParaRPr/>
           </a:p>
         </p:txBody>
       </p:sp>
@@ -20278,6 +20302,7 @@
           <a:lstStyle/>
           <a:p>
             <a:pPr algn="ctr"/>
+            <a:endParaRPr/>
           </a:p>
         </p:txBody>
       </p:sp>
@@ -20321,6 +20346,7 @@
           <a:lstStyle/>
           <a:p>
             <a:pPr algn="ctr"/>
+            <a:endParaRPr/>
           </a:p>
         </p:txBody>
       </p:sp>
@@ -20436,6 +20462,7 @@
           <a:lstStyle/>
           <a:p>
             <a:pPr algn="ctr"/>
+            <a:endParaRPr/>
           </a:p>
         </p:txBody>
       </p:sp>
@@ -20479,6 +20506,7 @@
           <a:lstStyle/>
           <a:p>
             <a:pPr algn="ctr"/>
+            <a:endParaRPr/>
           </a:p>
         </p:txBody>
       </p:sp>
@@ -20594,6 +20622,7 @@
           <a:lstStyle/>
           <a:p>
             <a:pPr algn="ctr"/>
+            <a:endParaRPr/>
           </a:p>
         </p:txBody>
       </p:sp>
@@ -20637,6 +20666,7 @@
           <a:lstStyle/>
           <a:p>
             <a:pPr algn="ctr"/>
+            <a:endParaRPr/>
           </a:p>
         </p:txBody>
       </p:sp>
@@ -20719,7 +20749,7 @@
 </file>
 
 <file path=ppt/slides/slide5.xml><?xml version="1.0" encoding="utf-8"?>
-<p:sld xmlns:a="http://schemas.openxmlformats.org/drawingml/2006/main" xmlns:p="http://schemas.openxmlformats.org/presentationml/2006/main" xmlns:r="http://schemas.openxmlformats.org/officeDocument/2006/relationships">
+<p:sld xmlns:a="http://schemas.openxmlformats.org/drawingml/2006/main" xmlns:r="http://schemas.openxmlformats.org/officeDocument/2006/relationships" xmlns:p="http://schemas.openxmlformats.org/presentationml/2006/main">
   <p:cSld>
     <p:spTree>
       <p:nvGrpSpPr>
@@ -20727,7 +20757,14 @@
         <p:cNvGrpSpPr/>
         <p:nvPr/>
       </p:nvGrpSpPr>
-      <p:grpSpPr/>
+      <p:grpSpPr>
+        <a:xfrm>
+          <a:off x="0" y="0"/>
+          <a:ext cx="0" cy="0"/>
+          <a:chOff x="0" y="0"/>
+          <a:chExt cx="0" cy="0"/>
+        </a:xfrm>
+      </p:grpSpPr>
       <p:sp>
         <p:nvSpPr>
           <p:cNvPr id="2" name="Rectangle 1"/>
@@ -20768,6 +20805,7 @@
           <a:lstStyle/>
           <a:p>
             <a:pPr algn="ctr"/>
+            <a:endParaRPr/>
           </a:p>
         </p:txBody>
       </p:sp>
@@ -20913,6 +20951,7 @@
           <a:lstStyle/>
           <a:p>
             <a:pPr algn="ctr"/>
+            <a:endParaRPr/>
           </a:p>
         </p:txBody>
       </p:sp>
@@ -21025,6 +21064,7 @@
           <a:lstStyle/>
           <a:p>
             <a:pPr algn="ctr"/>
+            <a:endParaRPr/>
           </a:p>
         </p:txBody>
       </p:sp>
@@ -21173,6 +21213,7 @@
           <a:lstStyle/>
           <a:p>
             <a:pPr algn="ctr"/>
+            <a:endParaRPr/>
           </a:p>
         </p:txBody>
       </p:sp>
@@ -21321,6 +21362,7 @@
           <a:lstStyle/>
           <a:p>
             <a:pPr algn="ctr"/>
+            <a:endParaRPr/>
           </a:p>
         </p:txBody>
       </p:sp>
@@ -21469,6 +21511,7 @@
           <a:lstStyle/>
           <a:p>
             <a:pPr algn="ctr"/>
+            <a:endParaRPr/>
           </a:p>
         </p:txBody>
       </p:sp>
@@ -21586,7 +21629,7 @@
 </file>
 
 <file path=ppt/slides/slide6.xml><?xml version="1.0" encoding="utf-8"?>
-<p:sld xmlns:a="http://schemas.openxmlformats.org/drawingml/2006/main" xmlns:p="http://schemas.openxmlformats.org/presentationml/2006/main" xmlns:r="http://schemas.openxmlformats.org/officeDocument/2006/relationships">
+<p:sld xmlns:a="http://schemas.openxmlformats.org/drawingml/2006/main" xmlns:r="http://schemas.openxmlformats.org/officeDocument/2006/relationships" xmlns:p="http://schemas.openxmlformats.org/presentationml/2006/main">
   <p:cSld>
     <p:spTree>
       <p:nvGrpSpPr>
@@ -21594,7 +21637,14 @@
         <p:cNvGrpSpPr/>
         <p:nvPr/>
       </p:nvGrpSpPr>
-      <p:grpSpPr/>
+      <p:grpSpPr>
+        <a:xfrm>
+          <a:off x="0" y="0"/>
+          <a:ext cx="0" cy="0"/>
+          <a:chOff x="0" y="0"/>
+          <a:chExt cx="0" cy="0"/>
+        </a:xfrm>
+      </p:grpSpPr>
       <p:sp>
         <p:nvSpPr>
           <p:cNvPr id="2" name="Rectangle 1"/>
@@ -21635,6 +21685,7 @@
           <a:lstStyle/>
           <a:p>
             <a:pPr algn="ctr"/>
+            <a:endParaRPr/>
           </a:p>
         </p:txBody>
       </p:sp>
@@ -21780,6 +21831,7 @@
           <a:lstStyle/>
           <a:p>
             <a:pPr algn="ctr"/>
+            <a:endParaRPr/>
           </a:p>
         </p:txBody>
       </p:sp>
@@ -21894,6 +21946,7 @@
           <a:lstStyle/>
           <a:p>
             <a:pPr algn="ctr"/>
+            <a:endParaRPr/>
           </a:p>
         </p:txBody>
       </p:sp>
@@ -21937,6 +21990,7 @@
           <a:lstStyle/>
           <a:p>
             <a:pPr algn="ctr"/>
+            <a:endParaRPr/>
           </a:p>
         </p:txBody>
       </p:sp>
@@ -22052,6 +22106,7 @@
           <a:lstStyle/>
           <a:p>
             <a:pPr algn="ctr"/>
+            <a:endParaRPr/>
           </a:p>
         </p:txBody>
       </p:sp>
@@ -22095,6 +22150,7 @@
           <a:lstStyle/>
           <a:p>
             <a:pPr algn="ctr"/>
+            <a:endParaRPr/>
           </a:p>
         </p:txBody>
       </p:sp>
@@ -22210,6 +22266,7 @@
           <a:lstStyle/>
           <a:p>
             <a:pPr algn="ctr"/>
+            <a:endParaRPr/>
           </a:p>
         </p:txBody>
       </p:sp>
@@ -22253,6 +22310,7 @@
           <a:lstStyle/>
           <a:p>
             <a:pPr algn="ctr"/>
+            <a:endParaRPr/>
           </a:p>
         </p:txBody>
       </p:sp>
@@ -22368,6 +22426,7 @@
           <a:lstStyle/>
           <a:p>
             <a:pPr algn="ctr"/>
+            <a:endParaRPr/>
           </a:p>
         </p:txBody>
       </p:sp>
@@ -22411,6 +22470,7 @@
           <a:lstStyle/>
           <a:p>
             <a:pPr algn="ctr"/>
+            <a:endParaRPr/>
           </a:p>
         </p:txBody>
       </p:sp>
@@ -22528,7 +22588,7 @@
 </file>
 
 <file path=ppt/slides/slide7.xml><?xml version="1.0" encoding="utf-8"?>
-<p:sld xmlns:a="http://schemas.openxmlformats.org/drawingml/2006/main" xmlns:p="http://schemas.openxmlformats.org/presentationml/2006/main" xmlns:r="http://schemas.openxmlformats.org/officeDocument/2006/relationships">
+<p:sld xmlns:a="http://schemas.openxmlformats.org/drawingml/2006/main" xmlns:r="http://schemas.openxmlformats.org/officeDocument/2006/relationships" xmlns:p="http://schemas.openxmlformats.org/presentationml/2006/main">
   <p:cSld>
     <p:spTree>
       <p:nvGrpSpPr>
@@ -22536,7 +22596,14 @@
         <p:cNvGrpSpPr/>
         <p:nvPr/>
       </p:nvGrpSpPr>
-      <p:grpSpPr/>
+      <p:grpSpPr>
+        <a:xfrm>
+          <a:off x="0" y="0"/>
+          <a:ext cx="0" cy="0"/>
+          <a:chOff x="0" y="0"/>
+          <a:chExt cx="0" cy="0"/>
+        </a:xfrm>
+      </p:grpSpPr>
       <p:sp>
         <p:nvSpPr>
           <p:cNvPr id="2" name="Rectangle 1"/>
@@ -22577,6 +22644,7 @@
           <a:lstStyle/>
           <a:p>
             <a:pPr algn="ctr"/>
+            <a:endParaRPr/>
           </a:p>
         </p:txBody>
       </p:sp>
@@ -22644,40 +22712,6 @@
                 <a:latin typeface="Aptos"/>
               </a:rPr>
               <a:t>Frontend Experience — Dashboard</a:t>
-            </a:r>
-          </a:p>
-        </p:txBody>
-      </p:sp>
-      <p:sp>
-        <p:nvSpPr>
-          <p:cNvPr id="5" name="TextBox 4"/>
-          <p:cNvSpPr txBox="1"/>
-          <p:nvPr/>
-        </p:nvSpPr>
-        <p:spPr>
-          <a:xfrm>
-            <a:off x="521207" y="1143000"/>
-            <a:ext cx="10789920" cy="365760"/>
-          </a:xfrm>
-          <a:prstGeom prst="rect">
-            <a:avLst/>
-          </a:prstGeom>
-          <a:noFill/>
-        </p:spPr>
-        <p:txBody>
-          <a:bodyPr wrap="none">
-            <a:spAutoFit/>
-          </a:bodyPr>
-          <a:lstStyle/>
-          <a:p>
-            <a:r>
-              <a:rPr sz="1100">
-                <a:solidFill>
-                  <a:srgbClr val="627081"/>
-                </a:solidFill>
-                <a:latin typeface="Aptos"/>
-              </a:rPr>
-              <a:t>Placeholder for your actual React dashboard screenshot.</a:t>
             </a:r>
           </a:p>
         </p:txBody>
@@ -22722,6 +22756,7 @@
           <a:lstStyle/>
           <a:p>
             <a:pPr algn="ctr"/>
+            <a:endParaRPr/>
           </a:p>
         </p:txBody>
       </p:sp>
@@ -22790,210 +22825,6 @@
                 <a:latin typeface="Aptos"/>
               </a:rPr>
               <a:t>7</a:t>
-            </a:r>
-          </a:p>
-        </p:txBody>
-      </p:sp>
-      <p:sp>
-        <p:nvSpPr>
-          <p:cNvPr id="9" name="Rounded Rectangle 8"/>
-          <p:cNvSpPr/>
-          <p:nvPr/>
-        </p:nvSpPr>
-        <p:spPr>
-          <a:xfrm>
-            <a:off x="594360" y="1874519"/>
-            <a:ext cx="7406640" cy="4069080"/>
-          </a:xfrm>
-          <a:prstGeom prst="roundRect">
-            <a:avLst/>
-          </a:prstGeom>
-          <a:solidFill>
-            <a:srgbClr val="EEF2F7"/>
-          </a:solidFill>
-          <a:ln w="19050">
-            <a:solidFill>
-              <a:srgbClr val="2A69B4"/>
-            </a:solidFill>
-            <a:prstDash val="dash"/>
-          </a:ln>
-        </p:spPr>
-        <p:style>
-          <a:lnRef idx="1">
-            <a:schemeClr val="accent1"/>
-          </a:lnRef>
-          <a:fillRef idx="3">
-            <a:schemeClr val="accent1"/>
-          </a:fillRef>
-          <a:effectRef idx="2">
-            <a:schemeClr val="accent1"/>
-          </a:effectRef>
-          <a:fontRef idx="minor">
-            <a:schemeClr val="lt1"/>
-          </a:fontRef>
-        </p:style>
-        <p:txBody>
-          <a:bodyPr rtlCol="0" anchor="ctr"/>
-          <a:lstStyle/>
-          <a:p>
-            <a:pPr algn="ctr"/>
-          </a:p>
-        </p:txBody>
-      </p:sp>
-      <p:sp>
-        <p:nvSpPr>
-          <p:cNvPr id="10" name="Rectangle 9"/>
-          <p:cNvSpPr/>
-          <p:nvPr/>
-        </p:nvSpPr>
-        <p:spPr>
-          <a:xfrm>
-            <a:off x="3886200" y="3451860"/>
-            <a:ext cx="822960" cy="658368"/>
-          </a:xfrm>
-          <a:prstGeom prst="rect">
-            <a:avLst/>
-          </a:prstGeom>
-          <a:solidFill>
-            <a:srgbClr val="FFFFFF"/>
-          </a:solidFill>
-          <a:ln>
-            <a:solidFill>
-              <a:srgbClr val="2A69B4"/>
-            </a:solidFill>
-          </a:ln>
-        </p:spPr>
-        <p:style>
-          <a:lnRef idx="1">
-            <a:schemeClr val="accent1"/>
-          </a:lnRef>
-          <a:fillRef idx="3">
-            <a:schemeClr val="accent1"/>
-          </a:fillRef>
-          <a:effectRef idx="2">
-            <a:schemeClr val="accent1"/>
-          </a:effectRef>
-          <a:fontRef idx="minor">
-            <a:schemeClr val="lt1"/>
-          </a:fontRef>
-        </p:style>
-        <p:txBody>
-          <a:bodyPr rtlCol="0" anchor="ctr"/>
-          <a:lstStyle/>
-          <a:p>
-            <a:pPr algn="ctr"/>
-          </a:p>
-        </p:txBody>
-      </p:sp>
-      <p:sp>
-        <p:nvSpPr>
-          <p:cNvPr id="11" name="Oval 10"/>
-          <p:cNvSpPr/>
-          <p:nvPr/>
-        </p:nvSpPr>
-        <p:spPr>
-          <a:xfrm>
-            <a:off x="4343400" y="3589020"/>
-            <a:ext cx="109728" cy="109728"/>
-          </a:xfrm>
-          <a:prstGeom prst="ellipse">
-            <a:avLst/>
-          </a:prstGeom>
-          <a:solidFill>
-            <a:srgbClr val="2A69B4"/>
-          </a:solidFill>
-          <a:ln>
-            <a:noFill/>
-          </a:ln>
-        </p:spPr>
-        <p:style>
-          <a:lnRef idx="1">
-            <a:schemeClr val="accent1"/>
-          </a:lnRef>
-          <a:fillRef idx="3">
-            <a:schemeClr val="accent1"/>
-          </a:fillRef>
-          <a:effectRef idx="2">
-            <a:schemeClr val="accent1"/>
-          </a:effectRef>
-          <a:fontRef idx="minor">
-            <a:schemeClr val="lt1"/>
-          </a:fontRef>
-        </p:style>
-        <p:txBody>
-          <a:bodyPr rtlCol="0" anchor="ctr"/>
-          <a:lstStyle/>
-          <a:p>
-            <a:pPr algn="ctr"/>
-          </a:p>
-        </p:txBody>
-      </p:sp>
-      <p:sp>
-        <p:nvSpPr>
-          <p:cNvPr id="12" name="TextBox 11"/>
-          <p:cNvSpPr txBox="1"/>
-          <p:nvPr/>
-        </p:nvSpPr>
-        <p:spPr>
-          <a:xfrm>
-            <a:off x="868680" y="4183380"/>
-            <a:ext cx="6858000" cy="320040"/>
-          </a:xfrm>
-          <a:prstGeom prst="rect">
-            <a:avLst/>
-          </a:prstGeom>
-          <a:noFill/>
-        </p:spPr>
-        <p:txBody>
-          <a:bodyPr wrap="square" anchor="t">
-            <a:spAutoFit/>
-          </a:bodyPr>
-          <a:lstStyle/>
-          <a:p>
-            <a:pPr algn="ctr"/>
-            <a:r>
-              <a:rPr sz="1500" b="1">
-                <a:solidFill>
-                  <a:srgbClr val="122B4C"/>
-                </a:solidFill>
-                <a:latin typeface="Aptos"/>
-              </a:rPr>
-              <a:t>PASTE DASHBOARD SCREENSHOT HERE</a:t>
-            </a:r>
-          </a:p>
-        </p:txBody>
-      </p:sp>
-      <p:sp>
-        <p:nvSpPr>
-          <p:cNvPr id="13" name="TextBox 12"/>
-          <p:cNvSpPr txBox="1"/>
-          <p:nvPr/>
-        </p:nvSpPr>
-        <p:spPr>
-          <a:xfrm>
-            <a:off x="868680" y="4530852"/>
-            <a:ext cx="6858000" cy="274320"/>
-          </a:xfrm>
-          <a:prstGeom prst="rect">
-            <a:avLst/>
-          </a:prstGeom>
-          <a:noFill/>
-        </p:spPr>
-        <p:txBody>
-          <a:bodyPr wrap="square" anchor="t">
-            <a:spAutoFit/>
-          </a:bodyPr>
-          <a:lstStyle/>
-          <a:p>
-            <a:pPr algn="ctr"/>
-            <a:r>
-              <a:rPr sz="950" b="0">
-                <a:solidFill>
-                  <a:srgbClr val="627081"/>
-                </a:solidFill>
-                <a:latin typeface="Aptos"/>
-              </a:rPr>
-              <a:t>Replace with actual frontend screenshot</a:t>
             </a:r>
           </a:p>
         </p:txBody>
@@ -23040,6 +22871,7 @@
           <a:lstStyle/>
           <a:p>
             <a:pPr algn="ctr"/>
+            <a:endParaRPr/>
           </a:p>
         </p:txBody>
       </p:sp>
@@ -23083,6 +22915,7 @@
           <a:lstStyle/>
           <a:p>
             <a:pPr algn="ctr"/>
+            <a:endParaRPr/>
           </a:p>
         </p:txBody>
       </p:sp>
@@ -23198,6 +23031,7 @@
           <a:lstStyle/>
           <a:p>
             <a:pPr algn="ctr"/>
+            <a:endParaRPr/>
           </a:p>
         </p:txBody>
       </p:sp>
@@ -23241,6 +23075,7 @@
           <a:lstStyle/>
           <a:p>
             <a:pPr algn="ctr"/>
+            <a:endParaRPr/>
           </a:p>
         </p:txBody>
       </p:sp>
@@ -23356,6 +23191,7 @@
           <a:lstStyle/>
           <a:p>
             <a:pPr algn="ctr"/>
+            <a:endParaRPr/>
           </a:p>
         </p:txBody>
       </p:sp>
@@ -23399,6 +23235,7 @@
           <a:lstStyle/>
           <a:p>
             <a:pPr algn="ctr"/>
+            <a:endParaRPr/>
           </a:p>
         </p:txBody>
       </p:sp>
@@ -23472,6 +23309,36 @@
           </a:p>
         </p:txBody>
       </p:sp>
+      <p:pic>
+        <p:nvPicPr>
+          <p:cNvPr id="26" name="Picture 25">
+            <a:extLst>
+              <a:ext uri="{FF2B5EF4-FFF2-40B4-BE49-F238E27FC236}">
+                <a16:creationId xmlns:a16="http://schemas.microsoft.com/office/drawing/2014/main" id="{7B5D8285-0C1C-E230-FDF8-A74F68CC1B1E}"/>
+              </a:ext>
+            </a:extLst>
+          </p:cNvPr>
+          <p:cNvPicPr>
+            <a:picLocks noChangeAspect="1"/>
+          </p:cNvPicPr>
+          <p:nvPr/>
+        </p:nvPicPr>
+        <p:blipFill>
+          <a:blip r:embed="rId2"/>
+          <a:stretch>
+            <a:fillRect/>
+          </a:stretch>
+        </p:blipFill>
+        <p:spPr>
+          <a:xfrm>
+            <a:off x="1133067" y="1635760"/>
+            <a:ext cx="5993947" cy="4734560"/>
+          </a:xfrm>
+          <a:prstGeom prst="rect">
+            <a:avLst/>
+          </a:prstGeom>
+        </p:spPr>
+      </p:pic>
     </p:spTree>
   </p:cSld>
   <p:clrMapOvr>
@@ -23481,7 +23348,7 @@
 </file>
 
 <file path=ppt/slides/slide8.xml><?xml version="1.0" encoding="utf-8"?>
-<p:sld xmlns:a="http://schemas.openxmlformats.org/drawingml/2006/main" xmlns:p="http://schemas.openxmlformats.org/presentationml/2006/main" xmlns:r="http://schemas.openxmlformats.org/officeDocument/2006/relationships">
+<p:sld xmlns:a="http://schemas.openxmlformats.org/drawingml/2006/main" xmlns:r="http://schemas.openxmlformats.org/officeDocument/2006/relationships" xmlns:p="http://schemas.openxmlformats.org/presentationml/2006/main">
   <p:cSld>
     <p:spTree>
       <p:nvGrpSpPr>
@@ -23489,7 +23356,14 @@
         <p:cNvGrpSpPr/>
         <p:nvPr/>
       </p:nvGrpSpPr>
-      <p:grpSpPr/>
+      <p:grpSpPr>
+        <a:xfrm>
+          <a:off x="0" y="0"/>
+          <a:ext cx="0" cy="0"/>
+          <a:chOff x="0" y="0"/>
+          <a:chExt cx="0" cy="0"/>
+        </a:xfrm>
+      </p:grpSpPr>
       <p:sp>
         <p:nvSpPr>
           <p:cNvPr id="2" name="Rectangle 1"/>
@@ -23530,6 +23404,7 @@
           <a:lstStyle/>
           <a:p>
             <a:pPr algn="ctr"/>
+            <a:endParaRPr/>
           </a:p>
         </p:txBody>
       </p:sp>
@@ -23597,40 +23472,6 @@
                 <a:latin typeface="Aptos"/>
               </a:rPr>
               <a:t>Frontend Experience — Customer Search</a:t>
-            </a:r>
-          </a:p>
-        </p:txBody>
-      </p:sp>
-      <p:sp>
-        <p:nvSpPr>
-          <p:cNvPr id="5" name="TextBox 4"/>
-          <p:cNvSpPr txBox="1"/>
-          <p:nvPr/>
-        </p:nvSpPr>
-        <p:spPr>
-          <a:xfrm>
-            <a:off x="521207" y="1143000"/>
-            <a:ext cx="10789920" cy="365760"/>
-          </a:xfrm>
-          <a:prstGeom prst="rect">
-            <a:avLst/>
-          </a:prstGeom>
-          <a:noFill/>
-        </p:spPr>
-        <p:txBody>
-          <a:bodyPr wrap="none">
-            <a:spAutoFit/>
-          </a:bodyPr>
-          <a:lstStyle/>
-          <a:p>
-            <a:r>
-              <a:rPr sz="1100">
-                <a:solidFill>
-                  <a:srgbClr val="627081"/>
-                </a:solidFill>
-                <a:latin typeface="Aptos"/>
-              </a:rPr>
-              <a:t>Placeholder for your customer profile/search screen.</a:t>
             </a:r>
           </a:p>
         </p:txBody>
@@ -23675,6 +23516,7 @@
           <a:lstStyle/>
           <a:p>
             <a:pPr algn="ctr"/>
+            <a:endParaRPr/>
           </a:p>
         </p:txBody>
       </p:sp>
@@ -23743,210 +23585,6 @@
                 <a:latin typeface="Aptos"/>
               </a:rPr>
               <a:t>8</a:t>
-            </a:r>
-          </a:p>
-        </p:txBody>
-      </p:sp>
-      <p:sp>
-        <p:nvSpPr>
-          <p:cNvPr id="9" name="Rounded Rectangle 8"/>
-          <p:cNvSpPr/>
-          <p:nvPr/>
-        </p:nvSpPr>
-        <p:spPr>
-          <a:xfrm>
-            <a:off x="594360" y="1874519"/>
-            <a:ext cx="7406640" cy="4069080"/>
-          </a:xfrm>
-          <a:prstGeom prst="roundRect">
-            <a:avLst/>
-          </a:prstGeom>
-          <a:solidFill>
-            <a:srgbClr val="EEF2F7"/>
-          </a:solidFill>
-          <a:ln w="19050">
-            <a:solidFill>
-              <a:srgbClr val="2A69B4"/>
-            </a:solidFill>
-            <a:prstDash val="dash"/>
-          </a:ln>
-        </p:spPr>
-        <p:style>
-          <a:lnRef idx="1">
-            <a:schemeClr val="accent1"/>
-          </a:lnRef>
-          <a:fillRef idx="3">
-            <a:schemeClr val="accent1"/>
-          </a:fillRef>
-          <a:effectRef idx="2">
-            <a:schemeClr val="accent1"/>
-          </a:effectRef>
-          <a:fontRef idx="minor">
-            <a:schemeClr val="lt1"/>
-          </a:fontRef>
-        </p:style>
-        <p:txBody>
-          <a:bodyPr rtlCol="0" anchor="ctr"/>
-          <a:lstStyle/>
-          <a:p>
-            <a:pPr algn="ctr"/>
-          </a:p>
-        </p:txBody>
-      </p:sp>
-      <p:sp>
-        <p:nvSpPr>
-          <p:cNvPr id="10" name="Rectangle 9"/>
-          <p:cNvSpPr/>
-          <p:nvPr/>
-        </p:nvSpPr>
-        <p:spPr>
-          <a:xfrm>
-            <a:off x="3886200" y="3451860"/>
-            <a:ext cx="822960" cy="658368"/>
-          </a:xfrm>
-          <a:prstGeom prst="rect">
-            <a:avLst/>
-          </a:prstGeom>
-          <a:solidFill>
-            <a:srgbClr val="FFFFFF"/>
-          </a:solidFill>
-          <a:ln>
-            <a:solidFill>
-              <a:srgbClr val="2A69B4"/>
-            </a:solidFill>
-          </a:ln>
-        </p:spPr>
-        <p:style>
-          <a:lnRef idx="1">
-            <a:schemeClr val="accent1"/>
-          </a:lnRef>
-          <a:fillRef idx="3">
-            <a:schemeClr val="accent1"/>
-          </a:fillRef>
-          <a:effectRef idx="2">
-            <a:schemeClr val="accent1"/>
-          </a:effectRef>
-          <a:fontRef idx="minor">
-            <a:schemeClr val="lt1"/>
-          </a:fontRef>
-        </p:style>
-        <p:txBody>
-          <a:bodyPr rtlCol="0" anchor="ctr"/>
-          <a:lstStyle/>
-          <a:p>
-            <a:pPr algn="ctr"/>
-          </a:p>
-        </p:txBody>
-      </p:sp>
-      <p:sp>
-        <p:nvSpPr>
-          <p:cNvPr id="11" name="Oval 10"/>
-          <p:cNvSpPr/>
-          <p:nvPr/>
-        </p:nvSpPr>
-        <p:spPr>
-          <a:xfrm>
-            <a:off x="4343400" y="3589020"/>
-            <a:ext cx="109728" cy="109728"/>
-          </a:xfrm>
-          <a:prstGeom prst="ellipse">
-            <a:avLst/>
-          </a:prstGeom>
-          <a:solidFill>
-            <a:srgbClr val="2A69B4"/>
-          </a:solidFill>
-          <a:ln>
-            <a:noFill/>
-          </a:ln>
-        </p:spPr>
-        <p:style>
-          <a:lnRef idx="1">
-            <a:schemeClr val="accent1"/>
-          </a:lnRef>
-          <a:fillRef idx="3">
-            <a:schemeClr val="accent1"/>
-          </a:fillRef>
-          <a:effectRef idx="2">
-            <a:schemeClr val="accent1"/>
-          </a:effectRef>
-          <a:fontRef idx="minor">
-            <a:schemeClr val="lt1"/>
-          </a:fontRef>
-        </p:style>
-        <p:txBody>
-          <a:bodyPr rtlCol="0" anchor="ctr"/>
-          <a:lstStyle/>
-          <a:p>
-            <a:pPr algn="ctr"/>
-          </a:p>
-        </p:txBody>
-      </p:sp>
-      <p:sp>
-        <p:nvSpPr>
-          <p:cNvPr id="12" name="TextBox 11"/>
-          <p:cNvSpPr txBox="1"/>
-          <p:nvPr/>
-        </p:nvSpPr>
-        <p:spPr>
-          <a:xfrm>
-            <a:off x="868680" y="4183380"/>
-            <a:ext cx="6858000" cy="320040"/>
-          </a:xfrm>
-          <a:prstGeom prst="rect">
-            <a:avLst/>
-          </a:prstGeom>
-          <a:noFill/>
-        </p:spPr>
-        <p:txBody>
-          <a:bodyPr wrap="square" anchor="t">
-            <a:spAutoFit/>
-          </a:bodyPr>
-          <a:lstStyle/>
-          <a:p>
-            <a:pPr algn="ctr"/>
-            <a:r>
-              <a:rPr sz="1500" b="1">
-                <a:solidFill>
-                  <a:srgbClr val="122B4C"/>
-                </a:solidFill>
-                <a:latin typeface="Aptos"/>
-              </a:rPr>
-              <a:t>PASTE CUSTOMER SEARCH SCREENSHOT HERE</a:t>
-            </a:r>
-          </a:p>
-        </p:txBody>
-      </p:sp>
-      <p:sp>
-        <p:nvSpPr>
-          <p:cNvPr id="13" name="TextBox 12"/>
-          <p:cNvSpPr txBox="1"/>
-          <p:nvPr/>
-        </p:nvSpPr>
-        <p:spPr>
-          <a:xfrm>
-            <a:off x="868680" y="4530852"/>
-            <a:ext cx="6858000" cy="274320"/>
-          </a:xfrm>
-          <a:prstGeom prst="rect">
-            <a:avLst/>
-          </a:prstGeom>
-          <a:noFill/>
-        </p:spPr>
-        <p:txBody>
-          <a:bodyPr wrap="square" anchor="t">
-            <a:spAutoFit/>
-          </a:bodyPr>
-          <a:lstStyle/>
-          <a:p>
-            <a:pPr algn="ctr"/>
-            <a:r>
-              <a:rPr sz="950" b="0">
-                <a:solidFill>
-                  <a:srgbClr val="627081"/>
-                </a:solidFill>
-                <a:latin typeface="Aptos"/>
-              </a:rPr>
-              <a:t>Replace with actual frontend screenshot</a:t>
             </a:r>
           </a:p>
         </p:txBody>
@@ -23993,6 +23631,7 @@
           <a:lstStyle/>
           <a:p>
             <a:pPr algn="ctr"/>
+            <a:endParaRPr/>
           </a:p>
         </p:txBody>
       </p:sp>
@@ -24036,6 +23675,7 @@
           <a:lstStyle/>
           <a:p>
             <a:pPr algn="ctr"/>
+            <a:endParaRPr/>
           </a:p>
         </p:txBody>
       </p:sp>
@@ -24151,6 +23791,7 @@
           <a:lstStyle/>
           <a:p>
             <a:pPr algn="ctr"/>
+            <a:endParaRPr/>
           </a:p>
         </p:txBody>
       </p:sp>
@@ -24194,6 +23835,7 @@
           <a:lstStyle/>
           <a:p>
             <a:pPr algn="ctr"/>
+            <a:endParaRPr/>
           </a:p>
         </p:txBody>
       </p:sp>
@@ -24309,6 +23951,7 @@
           <a:lstStyle/>
           <a:p>
             <a:pPr algn="ctr"/>
+            <a:endParaRPr/>
           </a:p>
         </p:txBody>
       </p:sp>
@@ -24352,6 +23995,7 @@
           <a:lstStyle/>
           <a:p>
             <a:pPr algn="ctr"/>
+            <a:endParaRPr/>
           </a:p>
         </p:txBody>
       </p:sp>
@@ -24425,6 +24069,36 @@
           </a:p>
         </p:txBody>
       </p:sp>
+      <p:pic>
+        <p:nvPicPr>
+          <p:cNvPr id="26" name="Picture 25">
+            <a:extLst>
+              <a:ext uri="{FF2B5EF4-FFF2-40B4-BE49-F238E27FC236}">
+                <a16:creationId xmlns:a16="http://schemas.microsoft.com/office/drawing/2014/main" id="{E72FFAFA-EF1A-0043-00C1-24333EBF2194}"/>
+              </a:ext>
+            </a:extLst>
+          </p:cNvPr>
+          <p:cNvPicPr>
+            <a:picLocks noChangeAspect="1"/>
+          </p:cNvPicPr>
+          <p:nvPr/>
+        </p:nvPicPr>
+        <p:blipFill>
+          <a:blip r:embed="rId2"/>
+          <a:stretch>
+            <a:fillRect/>
+          </a:stretch>
+        </p:blipFill>
+        <p:spPr>
+          <a:xfrm>
+            <a:off x="614363" y="2018348"/>
+            <a:ext cx="6442075" cy="3664585"/>
+          </a:xfrm>
+          <a:prstGeom prst="rect">
+            <a:avLst/>
+          </a:prstGeom>
+        </p:spPr>
+      </p:pic>
     </p:spTree>
   </p:cSld>
   <p:clrMapOvr>
@@ -24434,7 +24108,7 @@
 </file>
 
 <file path=ppt/slides/slide9.xml><?xml version="1.0" encoding="utf-8"?>
-<p:sld xmlns:a="http://schemas.openxmlformats.org/drawingml/2006/main" xmlns:p="http://schemas.openxmlformats.org/presentationml/2006/main" xmlns:r="http://schemas.openxmlformats.org/officeDocument/2006/relationships">
+<p:sld xmlns:a="http://schemas.openxmlformats.org/drawingml/2006/main" xmlns:r="http://schemas.openxmlformats.org/officeDocument/2006/relationships" xmlns:p="http://schemas.openxmlformats.org/presentationml/2006/main">
   <p:cSld>
     <p:spTree>
       <p:nvGrpSpPr>
@@ -24442,7 +24116,14 @@
         <p:cNvGrpSpPr/>
         <p:nvPr/>
       </p:nvGrpSpPr>
-      <p:grpSpPr/>
+      <p:grpSpPr>
+        <a:xfrm>
+          <a:off x="0" y="0"/>
+          <a:ext cx="0" cy="0"/>
+          <a:chOff x="0" y="0"/>
+          <a:chExt cx="0" cy="0"/>
+        </a:xfrm>
+      </p:grpSpPr>
       <p:sp>
         <p:nvSpPr>
           <p:cNvPr id="2" name="Rectangle 1"/>
@@ -24483,6 +24164,7 @@
           <a:lstStyle/>
           <a:p>
             <a:pPr algn="ctr"/>
+            <a:endParaRPr/>
           </a:p>
         </p:txBody>
       </p:sp>
@@ -24550,40 +24232,6 @@
                 <a:latin typeface="Aptos"/>
               </a:rPr>
               <a:t>Frontend Experience — High-Risk Customers</a:t>
-            </a:r>
-          </a:p>
-        </p:txBody>
-      </p:sp>
-      <p:sp>
-        <p:nvSpPr>
-          <p:cNvPr id="5" name="TextBox 4"/>
-          <p:cNvSpPr txBox="1"/>
-          <p:nvPr/>
-        </p:nvSpPr>
-        <p:spPr>
-          <a:xfrm>
-            <a:off x="521207" y="1143000"/>
-            <a:ext cx="10789920" cy="365760"/>
-          </a:xfrm>
-          <a:prstGeom prst="rect">
-            <a:avLst/>
-          </a:prstGeom>
-          <a:noFill/>
-        </p:spPr>
-        <p:txBody>
-          <a:bodyPr wrap="none">
-            <a:spAutoFit/>
-          </a:bodyPr>
-          <a:lstStyle/>
-          <a:p>
-            <a:r>
-              <a:rPr sz="1100">
-                <a:solidFill>
-                  <a:srgbClr val="627081"/>
-                </a:solidFill>
-                <a:latin typeface="Aptos"/>
-              </a:rPr>
-              <a:t>Placeholder for the prioritization table used by the retention team.</a:t>
             </a:r>
           </a:p>
         </p:txBody>
@@ -24628,6 +24276,7 @@
           <a:lstStyle/>
           <a:p>
             <a:pPr algn="ctr"/>
+            <a:endParaRPr/>
           </a:p>
         </p:txBody>
       </p:sp>
@@ -24696,210 +24345,6 @@
                 <a:latin typeface="Aptos"/>
               </a:rPr>
               <a:t>9</a:t>
-            </a:r>
-          </a:p>
-        </p:txBody>
-      </p:sp>
-      <p:sp>
-        <p:nvSpPr>
-          <p:cNvPr id="9" name="Rounded Rectangle 8"/>
-          <p:cNvSpPr/>
-          <p:nvPr/>
-        </p:nvSpPr>
-        <p:spPr>
-          <a:xfrm>
-            <a:off x="594360" y="1874519"/>
-            <a:ext cx="7406640" cy="4069080"/>
-          </a:xfrm>
-          <a:prstGeom prst="roundRect">
-            <a:avLst/>
-          </a:prstGeom>
-          <a:solidFill>
-            <a:srgbClr val="EEF2F7"/>
-          </a:solidFill>
-          <a:ln w="19050">
-            <a:solidFill>
-              <a:srgbClr val="2A69B4"/>
-            </a:solidFill>
-            <a:prstDash val="dash"/>
-          </a:ln>
-        </p:spPr>
-        <p:style>
-          <a:lnRef idx="1">
-            <a:schemeClr val="accent1"/>
-          </a:lnRef>
-          <a:fillRef idx="3">
-            <a:schemeClr val="accent1"/>
-          </a:fillRef>
-          <a:effectRef idx="2">
-            <a:schemeClr val="accent1"/>
-          </a:effectRef>
-          <a:fontRef idx="minor">
-            <a:schemeClr val="lt1"/>
-          </a:fontRef>
-        </p:style>
-        <p:txBody>
-          <a:bodyPr rtlCol="0" anchor="ctr"/>
-          <a:lstStyle/>
-          <a:p>
-            <a:pPr algn="ctr"/>
-          </a:p>
-        </p:txBody>
-      </p:sp>
-      <p:sp>
-        <p:nvSpPr>
-          <p:cNvPr id="10" name="Rectangle 9"/>
-          <p:cNvSpPr/>
-          <p:nvPr/>
-        </p:nvSpPr>
-        <p:spPr>
-          <a:xfrm>
-            <a:off x="3886200" y="3451860"/>
-            <a:ext cx="822960" cy="658368"/>
-          </a:xfrm>
-          <a:prstGeom prst="rect">
-            <a:avLst/>
-          </a:prstGeom>
-          <a:solidFill>
-            <a:srgbClr val="FFFFFF"/>
-          </a:solidFill>
-          <a:ln>
-            <a:solidFill>
-              <a:srgbClr val="2A69B4"/>
-            </a:solidFill>
-          </a:ln>
-        </p:spPr>
-        <p:style>
-          <a:lnRef idx="1">
-            <a:schemeClr val="accent1"/>
-          </a:lnRef>
-          <a:fillRef idx="3">
-            <a:schemeClr val="accent1"/>
-          </a:fillRef>
-          <a:effectRef idx="2">
-            <a:schemeClr val="accent1"/>
-          </a:effectRef>
-          <a:fontRef idx="minor">
-            <a:schemeClr val="lt1"/>
-          </a:fontRef>
-        </p:style>
-        <p:txBody>
-          <a:bodyPr rtlCol="0" anchor="ctr"/>
-          <a:lstStyle/>
-          <a:p>
-            <a:pPr algn="ctr"/>
-          </a:p>
-        </p:txBody>
-      </p:sp>
-      <p:sp>
-        <p:nvSpPr>
-          <p:cNvPr id="11" name="Oval 10"/>
-          <p:cNvSpPr/>
-          <p:nvPr/>
-        </p:nvSpPr>
-        <p:spPr>
-          <a:xfrm>
-            <a:off x="4343400" y="3589020"/>
-            <a:ext cx="109728" cy="109728"/>
-          </a:xfrm>
-          <a:prstGeom prst="ellipse">
-            <a:avLst/>
-          </a:prstGeom>
-          <a:solidFill>
-            <a:srgbClr val="2A69B4"/>
-          </a:solidFill>
-          <a:ln>
-            <a:noFill/>
-          </a:ln>
-        </p:spPr>
-        <p:style>
-          <a:lnRef idx="1">
-            <a:schemeClr val="accent1"/>
-          </a:lnRef>
-          <a:fillRef idx="3">
-            <a:schemeClr val="accent1"/>
-          </a:fillRef>
-          <a:effectRef idx="2">
-            <a:schemeClr val="accent1"/>
-          </a:effectRef>
-          <a:fontRef idx="minor">
-            <a:schemeClr val="lt1"/>
-          </a:fontRef>
-        </p:style>
-        <p:txBody>
-          <a:bodyPr rtlCol="0" anchor="ctr"/>
-          <a:lstStyle/>
-          <a:p>
-            <a:pPr algn="ctr"/>
-          </a:p>
-        </p:txBody>
-      </p:sp>
-      <p:sp>
-        <p:nvSpPr>
-          <p:cNvPr id="12" name="TextBox 11"/>
-          <p:cNvSpPr txBox="1"/>
-          <p:nvPr/>
-        </p:nvSpPr>
-        <p:spPr>
-          <a:xfrm>
-            <a:off x="868680" y="4183380"/>
-            <a:ext cx="6858000" cy="320040"/>
-          </a:xfrm>
-          <a:prstGeom prst="rect">
-            <a:avLst/>
-          </a:prstGeom>
-          <a:noFill/>
-        </p:spPr>
-        <p:txBody>
-          <a:bodyPr wrap="square" anchor="t">
-            <a:spAutoFit/>
-          </a:bodyPr>
-          <a:lstStyle/>
-          <a:p>
-            <a:pPr algn="ctr"/>
-            <a:r>
-              <a:rPr sz="1500" b="1">
-                <a:solidFill>
-                  <a:srgbClr val="122B4C"/>
-                </a:solidFill>
-                <a:latin typeface="Aptos"/>
-              </a:rPr>
-              <a:t>PASTE HIGH-RISK CUSTOMER SCREENSHOT HERE</a:t>
-            </a:r>
-          </a:p>
-        </p:txBody>
-      </p:sp>
-      <p:sp>
-        <p:nvSpPr>
-          <p:cNvPr id="13" name="TextBox 12"/>
-          <p:cNvSpPr txBox="1"/>
-          <p:nvPr/>
-        </p:nvSpPr>
-        <p:spPr>
-          <a:xfrm>
-            <a:off x="868680" y="4530852"/>
-            <a:ext cx="6858000" cy="274320"/>
-          </a:xfrm>
-          <a:prstGeom prst="rect">
-            <a:avLst/>
-          </a:prstGeom>
-          <a:noFill/>
-        </p:spPr>
-        <p:txBody>
-          <a:bodyPr wrap="square" anchor="t">
-            <a:spAutoFit/>
-          </a:bodyPr>
-          <a:lstStyle/>
-          <a:p>
-            <a:pPr algn="ctr"/>
-            <a:r>
-              <a:rPr sz="950" b="0">
-                <a:solidFill>
-                  <a:srgbClr val="627081"/>
-                </a:solidFill>
-                <a:latin typeface="Aptos"/>
-              </a:rPr>
-              <a:t>Replace with actual frontend screenshot</a:t>
             </a:r>
           </a:p>
         </p:txBody>
@@ -24946,6 +24391,7 @@
           <a:lstStyle/>
           <a:p>
             <a:pPr algn="ctr"/>
+            <a:endParaRPr/>
           </a:p>
         </p:txBody>
       </p:sp>
@@ -24989,6 +24435,7 @@
           <a:lstStyle/>
           <a:p>
             <a:pPr algn="ctr"/>
+            <a:endParaRPr/>
           </a:p>
         </p:txBody>
       </p:sp>
@@ -25104,6 +24551,7 @@
           <a:lstStyle/>
           <a:p>
             <a:pPr algn="ctr"/>
+            <a:endParaRPr/>
           </a:p>
         </p:txBody>
       </p:sp>
@@ -25147,6 +24595,7 @@
           <a:lstStyle/>
           <a:p>
             <a:pPr algn="ctr"/>
+            <a:endParaRPr/>
           </a:p>
         </p:txBody>
       </p:sp>
@@ -25262,6 +24711,7 @@
           <a:lstStyle/>
           <a:p>
             <a:pPr algn="ctr"/>
+            <a:endParaRPr/>
           </a:p>
         </p:txBody>
       </p:sp>
@@ -25305,6 +24755,7 @@
           <a:lstStyle/>
           <a:p>
             <a:pPr algn="ctr"/>
+            <a:endParaRPr/>
           </a:p>
         </p:txBody>
       </p:sp>
@@ -25378,6 +24829,36 @@
           </a:p>
         </p:txBody>
       </p:sp>
+      <p:pic>
+        <p:nvPicPr>
+          <p:cNvPr id="26" name="Picture 25">
+            <a:extLst>
+              <a:ext uri="{FF2B5EF4-FFF2-40B4-BE49-F238E27FC236}">
+                <a16:creationId xmlns:a16="http://schemas.microsoft.com/office/drawing/2014/main" id="{0F6357DD-6209-6026-0F51-D7ED1383A725}"/>
+              </a:ext>
+            </a:extLst>
+          </p:cNvPr>
+          <p:cNvPicPr>
+            <a:picLocks noChangeAspect="1"/>
+          </p:cNvPicPr>
+          <p:nvPr/>
+        </p:nvPicPr>
+        <p:blipFill>
+          <a:blip r:embed="rId2"/>
+          <a:stretch>
+            <a:fillRect/>
+          </a:stretch>
+        </p:blipFill>
+        <p:spPr>
+          <a:xfrm>
+            <a:off x="1076306" y="1645920"/>
+            <a:ext cx="6056668" cy="4724400"/>
+          </a:xfrm>
+          <a:prstGeom prst="rect">
+            <a:avLst/>
+          </a:prstGeom>
+        </p:spPr>
+      </p:pic>
     </p:spTree>
   </p:cSld>
   <p:clrMapOvr>

</xml_diff>